<commit_message>
Added the first stretch goal slide for Video Traffic Input and Layered Roads
</commit_message>
<xml_diff>
--- a/Traffic Sim.pptx
+++ b/Traffic Sim.pptx
@@ -105,6 +105,11 @@
       </a:defRPr>
     </a:lvl9pPr>
   </p:defaultTextStyle>
+  <p:extLst>
+    <p:ext uri="{EFAFB233-063F-42B5-8137-9DF3F51BA10A}">
+      <p15:sldGuideLst xmlns:p15="http://schemas.microsoft.com/office/powerpoint/2012/main"/>
+    </p:ext>
+  </p:extLst>
 </p:presentation>
 </file>
 
@@ -527,7 +532,7 @@
           <a:p>
             <a:fld id="{D4F53BF9-51A7-479A-9F82-F12307D0B401}" type="datetimeFigureOut">
               <a:rPr lang="en-US" smtClean="0"/>
-              <a:t>10/27/2026</a:t>
+              <a:t>10/28/2026</a:t>
             </a:fld>
             <a:endParaRPr lang="en-US"/>
           </a:p>
@@ -852,7 +857,7 @@
           <a:p>
             <a:fld id="{D4F53BF9-51A7-479A-9F82-F12307D0B401}" type="datetimeFigureOut">
               <a:rPr lang="en-US" smtClean="0"/>
-              <a:t>10/27/2026</a:t>
+              <a:t>10/28/2026</a:t>
             </a:fld>
             <a:endParaRPr lang="en-US"/>
           </a:p>
@@ -1111,7 +1116,7 @@
           <a:p>
             <a:fld id="{D4F53BF9-51A7-479A-9F82-F12307D0B401}" type="datetimeFigureOut">
               <a:rPr lang="en-US" smtClean="0"/>
-              <a:t>10/27/2026</a:t>
+              <a:t>10/28/2026</a:t>
             </a:fld>
             <a:endParaRPr lang="en-US"/>
           </a:p>
@@ -1376,7 +1381,7 @@
           <a:p>
             <a:fld id="{D4F53BF9-51A7-479A-9F82-F12307D0B401}" type="datetimeFigureOut">
               <a:rPr lang="en-US" smtClean="0"/>
-              <a:t>10/27/2026</a:t>
+              <a:t>10/28/2026</a:t>
             </a:fld>
             <a:endParaRPr lang="en-US"/>
           </a:p>
@@ -1646,7 +1651,7 @@
           <a:p>
             <a:fld id="{D4F53BF9-51A7-479A-9F82-F12307D0B401}" type="datetimeFigureOut">
               <a:rPr lang="en-US" smtClean="0"/>
-              <a:t>10/27/2026</a:t>
+              <a:t>10/28/2026</a:t>
             </a:fld>
             <a:endParaRPr lang="en-US"/>
           </a:p>
@@ -1923,7 +1928,7 @@
           <a:p>
             <a:fld id="{D4F53BF9-51A7-479A-9F82-F12307D0B401}" type="datetimeFigureOut">
               <a:rPr lang="en-US" smtClean="0"/>
-              <a:t>10/27/2026</a:t>
+              <a:t>10/28/2026</a:t>
             </a:fld>
             <a:endParaRPr lang="en-US"/>
           </a:p>
@@ -2287,7 +2292,7 @@
           <a:p>
             <a:fld id="{D4F53BF9-51A7-479A-9F82-F12307D0B401}" type="datetimeFigureOut">
               <a:rPr lang="en-US" smtClean="0"/>
-              <a:t>10/27/2026</a:t>
+              <a:t>10/28/2026</a:t>
             </a:fld>
             <a:endParaRPr lang="en-US"/>
           </a:p>
@@ -2582,7 +2587,7 @@
           <a:p>
             <a:fld id="{D4F53BF9-51A7-479A-9F82-F12307D0B401}" type="datetimeFigureOut">
               <a:rPr lang="en-US" smtClean="0"/>
-              <a:t>10/27/2026</a:t>
+              <a:t>10/28/2026</a:t>
             </a:fld>
             <a:endParaRPr lang="en-US"/>
           </a:p>
@@ -2857,7 +2862,7 @@
           <a:p>
             <a:fld id="{D4F53BF9-51A7-479A-9F82-F12307D0B401}" type="datetimeFigureOut">
               <a:rPr lang="en-US" smtClean="0"/>
-              <a:t>10/27/2026</a:t>
+              <a:t>10/28/2026</a:t>
             </a:fld>
             <a:endParaRPr lang="en-US"/>
           </a:p>
@@ -3184,7 +3189,7 @@
           <a:p>
             <a:fld id="{D4F53BF9-51A7-479A-9F82-F12307D0B401}" type="datetimeFigureOut">
               <a:rPr lang="en-US" smtClean="0"/>
-              <a:t>10/27/2026</a:t>
+              <a:t>10/28/2026</a:t>
             </a:fld>
             <a:endParaRPr lang="en-US"/>
           </a:p>
@@ -3486,7 +3491,7 @@
           <a:p>
             <a:fld id="{D4F53BF9-51A7-479A-9F82-F12307D0B401}" type="datetimeFigureOut">
               <a:rPr lang="en-US" smtClean="0"/>
-              <a:t>10/27/2026</a:t>
+              <a:t>10/28/2026</a:t>
             </a:fld>
             <a:endParaRPr lang="en-US"/>
           </a:p>
@@ -3758,7 +3763,7 @@
           <a:p>
             <a:fld id="{D4F53BF9-51A7-479A-9F82-F12307D0B401}" type="datetimeFigureOut">
               <a:rPr lang="en-US" smtClean="0"/>
-              <a:t>10/27/2026</a:t>
+              <a:t>10/28/2026</a:t>
             </a:fld>
             <a:endParaRPr lang="en-US"/>
           </a:p>
@@ -4157,7 +4162,7 @@
           <a:p>
             <a:fld id="{D4F53BF9-51A7-479A-9F82-F12307D0B401}" type="datetimeFigureOut">
               <a:rPr lang="en-US" smtClean="0"/>
-              <a:t>10/27/2026</a:t>
+              <a:t>10/28/2026</a:t>
             </a:fld>
             <a:endParaRPr lang="en-US"/>
           </a:p>
@@ -4599,7 +4604,7 @@
           <a:p>
             <a:fld id="{D4F53BF9-51A7-479A-9F82-F12307D0B401}" type="datetimeFigureOut">
               <a:rPr lang="en-US" smtClean="0"/>
-              <a:t>10/27/2026</a:t>
+              <a:t>10/28/2026</a:t>
             </a:fld>
             <a:endParaRPr lang="en-US"/>
           </a:p>
@@ -4889,7 +4894,7 @@
           <a:p>
             <a:fld id="{D4F53BF9-51A7-479A-9F82-F12307D0B401}" type="datetimeFigureOut">
               <a:rPr lang="en-US" smtClean="0"/>
-              <a:t>10/27/2026</a:t>
+              <a:t>10/28/2026</a:t>
             </a:fld>
             <a:endParaRPr lang="en-US"/>
           </a:p>
@@ -5309,7 +5314,7 @@
           <a:p>
             <a:fld id="{D4F53BF9-51A7-479A-9F82-F12307D0B401}" type="datetimeFigureOut">
               <a:rPr lang="en-US" smtClean="0"/>
-              <a:t>10/27/2026</a:t>
+              <a:t>10/28/2026</a:t>
             </a:fld>
             <a:endParaRPr lang="en-US"/>
           </a:p>
@@ -5457,7 +5462,7 @@
           <a:p>
             <a:fld id="{D4F53BF9-51A7-479A-9F82-F12307D0B401}" type="datetimeFigureOut">
               <a:rPr lang="en-US" smtClean="0"/>
-              <a:t>10/27/2026</a:t>
+              <a:t>10/28/2026</a:t>
             </a:fld>
             <a:endParaRPr lang="en-US"/>
           </a:p>
@@ -5570,7 +5575,7 @@
           <a:p>
             <a:fld id="{D4F53BF9-51A7-479A-9F82-F12307D0B401}" type="datetimeFigureOut">
               <a:rPr lang="en-US" smtClean="0"/>
-              <a:t>10/27/2026</a:t>
+              <a:t>10/28/2026</a:t>
             </a:fld>
             <a:endParaRPr lang="en-US"/>
           </a:p>
@@ -5978,7 +5983,7 @@
           <a:p>
             <a:fld id="{D4F53BF9-51A7-479A-9F82-F12307D0B401}" type="datetimeFigureOut">
               <a:rPr lang="en-US" smtClean="0"/>
-              <a:t>10/27/2026</a:t>
+              <a:t>10/28/2026</a:t>
             </a:fld>
             <a:endParaRPr lang="en-US"/>
           </a:p>
@@ -6427,7 +6432,7 @@
           <a:p>
             <a:fld id="{D4F53BF9-51A7-479A-9F82-F12307D0B401}" type="datetimeFigureOut">
               <a:rPr lang="en-US" smtClean="0"/>
-              <a:t>10/27/2026</a:t>
+              <a:t>10/28/2026</a:t>
             </a:fld>
             <a:endParaRPr lang="en-US"/>
           </a:p>
@@ -6845,7 +6850,7 @@
           <a:p>
             <a:fld id="{D4F53BF9-51A7-479A-9F82-F12307D0B401}" type="datetimeFigureOut">
               <a:rPr lang="en-US" smtClean="0"/>
-              <a:t>10/27/2026</a:t>
+              <a:t>10/28/2026</a:t>
             </a:fld>
             <a:endParaRPr lang="en-US"/>
           </a:p>
@@ -7209,7 +7214,7 @@
           <a:p>
             <a:fld id="{D4F53BF9-51A7-479A-9F82-F12307D0B401}" type="datetimeFigureOut">
               <a:rPr lang="en-US" smtClean="0"/>
-              <a:t>10/27/2026</a:t>
+              <a:t>10/28/2026</a:t>
             </a:fld>
             <a:endParaRPr lang="en-US"/>
           </a:p>
@@ -7507,7 +7512,7 @@
           <a:p>
             <a:fld id="{D4F53BF9-51A7-479A-9F82-F12307D0B401}" type="datetimeFigureOut">
               <a:rPr lang="en-US" smtClean="0"/>
-              <a:t>10/27/2026</a:t>
+              <a:t>10/28/2026</a:t>
             </a:fld>
             <a:endParaRPr lang="en-US"/>
           </a:p>
@@ -7978,7 +7983,7 @@
           <a:p>
             <a:fld id="{D4F53BF9-51A7-479A-9F82-F12307D0B401}" type="datetimeFigureOut">
               <a:rPr lang="en-US" smtClean="0"/>
-              <a:t>10/27/2026</a:t>
+              <a:t>10/28/2026</a:t>
             </a:fld>
             <a:endParaRPr lang="en-US"/>
           </a:p>
@@ -8442,7 +8447,7 @@
           <a:p>
             <a:fld id="{D4F53BF9-51A7-479A-9F82-F12307D0B401}" type="datetimeFigureOut">
               <a:rPr lang="en-US" smtClean="0"/>
-              <a:t>10/27/2026</a:t>
+              <a:t>10/28/2026</a:t>
             </a:fld>
             <a:endParaRPr lang="en-US"/>
           </a:p>
@@ -8712,7 +8717,7 @@
           <a:p>
             <a:fld id="{D4F53BF9-51A7-479A-9F82-F12307D0B401}" type="datetimeFigureOut">
               <a:rPr lang="en-US" smtClean="0"/>
-              <a:t>10/27/2026</a:t>
+              <a:t>10/28/2026</a:t>
             </a:fld>
             <a:endParaRPr lang="en-US"/>
           </a:p>
@@ -8931,7 +8936,7 @@
           <a:p>
             <a:fld id="{D4F53BF9-51A7-479A-9F82-F12307D0B401}" type="datetimeFigureOut">
               <a:rPr lang="en-US" smtClean="0"/>
-              <a:t>10/27/2026</a:t>
+              <a:t>10/28/2026</a:t>
             </a:fld>
             <a:endParaRPr lang="en-US"/>
           </a:p>
@@ -9245,7 +9250,7 @@
           <a:p>
             <a:fld id="{D4F53BF9-51A7-479A-9F82-F12307D0B401}" type="datetimeFigureOut">
               <a:rPr lang="en-US" smtClean="0"/>
-              <a:t>10/27/2026</a:t>
+              <a:t>10/28/2026</a:t>
             </a:fld>
             <a:endParaRPr lang="en-US"/>
           </a:p>
@@ -10045,8 +10050,8 @@
         </p:nvSpPr>
         <p:spPr>
           <a:xfrm>
-            <a:off x="393192" y="346115"/>
-            <a:ext cx="11393424" cy="1494845"/>
+            <a:off x="605431" y="274926"/>
+            <a:ext cx="5355169" cy="1069848"/>
           </a:xfrm>
         </p:spPr>
         <p:txBody>
@@ -10057,31 +10062,31 @@
           <a:p>
             <a:r>
               <a:rPr lang="en-US" sz="4000" dirty="0"/>
-              <a:t>Example Slide Title</a:t>
-            </a:r>
-          </a:p>
-        </p:txBody>
-      </p:sp>
-      <p:sp>
-        <p:nvSpPr>
-          <p:cNvPr id="3" name="Content Placeholder 2">
-            <a:extLst>
-              <a:ext uri="{FF2B5EF4-FFF2-40B4-BE49-F238E27FC236}">
-                <a16:creationId xmlns:a16="http://schemas.microsoft.com/office/drawing/2014/main" id="{9B599297-9B04-6E34-D42D-263741081DD7}"/>
-              </a:ext>
-            </a:extLst>
-          </p:cNvPr>
-          <p:cNvSpPr>
-            <a:spLocks noGrp="1"/>
-          </p:cNvSpPr>
-          <p:nvPr>
-            <p:ph idx="1"/>
-          </p:nvPr>
-        </p:nvSpPr>
-        <p:spPr>
-          <a:xfrm>
-            <a:off x="722376" y="1331049"/>
-            <a:ext cx="10799064" cy="4683318"/>
+              <a:t>Stretch Goals</a:t>
+            </a:r>
+          </a:p>
+        </p:txBody>
+      </p:sp>
+      <p:sp>
+        <p:nvSpPr>
+          <p:cNvPr id="4" name="Text Placeholder 3">
+            <a:extLst>
+              <a:ext uri="{FF2B5EF4-FFF2-40B4-BE49-F238E27FC236}">
+                <a16:creationId xmlns:a16="http://schemas.microsoft.com/office/drawing/2014/main" id="{05641E9C-7073-207B-41C5-A5A94E56E0B1}"/>
+              </a:ext>
+            </a:extLst>
+          </p:cNvPr>
+          <p:cNvSpPr>
+            <a:spLocks noGrp="1"/>
+          </p:cNvSpPr>
+          <p:nvPr>
+            <p:ph type="body" idx="1"/>
+          </p:nvPr>
+        </p:nvSpPr>
+        <p:spPr>
+          <a:xfrm>
+            <a:off x="605431" y="1387408"/>
+            <a:ext cx="5157787" cy="709394"/>
           </a:xfrm>
         </p:spPr>
         <p:txBody>
@@ -10090,16 +10095,414 @@
           </a:bodyPr>
           <a:lstStyle/>
           <a:p>
-            <a:pPr marL="0" indent="0">
+            <a:pPr marL="0" marR="0" lvl="0" indent="0" algn="l" defTabSz="914400" rtl="0" eaLnBrk="1" fontAlgn="auto" latinLnBrk="0" hangingPunct="1">
+              <a:lnSpc>
+                <a:spcPct val="120000"/>
+              </a:lnSpc>
+              <a:spcBef>
+                <a:spcPts val="1000"/>
+              </a:spcBef>
+              <a:spcAft>
+                <a:spcPts val="0"/>
+              </a:spcAft>
+              <a:buClrTx/>
+              <a:buSzTx/>
+              <a:buFont typeface="Arial" panose="020B0604020202020204" pitchFamily="34" charset="0"/>
               <a:buNone/>
+              <a:tabLst/>
+              <a:defRPr/>
             </a:pPr>
             <a:r>
+              <a:rPr lang="en-US" sz="2800" b="0" cap="none" spc="0" dirty="0">
+                <a:solidFill>
+                  <a:srgbClr val="444742"/>
+                </a:solidFill>
+                <a:latin typeface="Univers Condensed Light"/>
+              </a:rPr>
+              <a:t>Traffic Video Input</a:t>
+            </a:r>
+            <a:endParaRPr kumimoji="0" lang="en-US" sz="2800" b="0" i="0" u="none" strike="noStrike" kern="1200" cap="none" spc="0" normalizeH="0" baseline="0" noProof="0" dirty="0">
+              <a:ln>
+                <a:noFill/>
+              </a:ln>
+              <a:solidFill>
+                <a:srgbClr val="444742"/>
+              </a:solidFill>
+              <a:effectLst/>
+              <a:uLnTx/>
+              <a:uFillTx/>
+              <a:latin typeface="Univers Condensed Light"/>
+              <a:ea typeface="+mn-ea"/>
+              <a:cs typeface="+mn-cs"/>
+            </a:endParaRPr>
+          </a:p>
+        </p:txBody>
+      </p:sp>
+      <p:sp>
+        <p:nvSpPr>
+          <p:cNvPr id="3" name="Content Placeholder 2">
+            <a:extLst>
+              <a:ext uri="{FF2B5EF4-FFF2-40B4-BE49-F238E27FC236}">
+                <a16:creationId xmlns:a16="http://schemas.microsoft.com/office/drawing/2014/main" id="{9B599297-9B04-6E34-D42D-263741081DD7}"/>
+              </a:ext>
+            </a:extLst>
+          </p:cNvPr>
+          <p:cNvSpPr>
+            <a:spLocks noGrp="1"/>
+          </p:cNvSpPr>
+          <p:nvPr>
+            <p:ph sz="half" idx="2"/>
+          </p:nvPr>
+        </p:nvSpPr>
+        <p:spPr>
+          <a:xfrm>
+            <a:off x="621858" y="2139436"/>
+            <a:ext cx="5157787" cy="3495253"/>
+          </a:xfrm>
+        </p:spPr>
+        <p:txBody>
+          <a:bodyPr>
+            <a:normAutofit/>
+          </a:bodyPr>
+          <a:lstStyle/>
+          <a:p>
+            <a:r>
               <a:rPr lang="en-US" sz="2400" dirty="0"/>
-              <a:t>Example slide body.</a:t>
-            </a:r>
-          </a:p>
-        </p:txBody>
-      </p:sp>
+              <a:t>Analyze a Provided Video</a:t>
+            </a:r>
+          </a:p>
+          <a:p>
+            <a:pPr lvl="1"/>
+            <a:r>
+              <a:rPr lang="en-US" sz="2400" dirty="0"/>
+              <a:t>User Efficiency Tool</a:t>
+            </a:r>
+          </a:p>
+          <a:p>
+            <a:r>
+              <a:rPr lang="en-US" sz="2400" dirty="0"/>
+              <a:t>Determine Traffic Data</a:t>
+            </a:r>
+          </a:p>
+          <a:p>
+            <a:pPr lvl="1"/>
+            <a:r>
+              <a:rPr lang="en-US" sz="2400" dirty="0"/>
+              <a:t>Traffic Flow Directions</a:t>
+            </a:r>
+          </a:p>
+          <a:p>
+            <a:pPr lvl="1"/>
+            <a:r>
+              <a:rPr lang="en-US" sz="2400" dirty="0"/>
+              <a:t>Traffic Density</a:t>
+            </a:r>
+          </a:p>
+          <a:p>
+            <a:r>
+              <a:rPr lang="en-US" sz="2400" dirty="0"/>
+              <a:t>Alter Simulation Parameters to Match</a:t>
+            </a:r>
+          </a:p>
+        </p:txBody>
+      </p:sp>
+      <p:sp>
+        <p:nvSpPr>
+          <p:cNvPr id="5" name="Text Placeholder 4">
+            <a:extLst>
+              <a:ext uri="{FF2B5EF4-FFF2-40B4-BE49-F238E27FC236}">
+                <a16:creationId xmlns:a16="http://schemas.microsoft.com/office/drawing/2014/main" id="{63D3E574-5441-7C65-04F7-1AE5ED31F3EA}"/>
+              </a:ext>
+            </a:extLst>
+          </p:cNvPr>
+          <p:cNvSpPr>
+            <a:spLocks noGrp="1"/>
+          </p:cNvSpPr>
+          <p:nvPr>
+            <p:ph type="body" sz="quarter" idx="3"/>
+          </p:nvPr>
+        </p:nvSpPr>
+        <p:spPr>
+          <a:xfrm>
+            <a:off x="6231402" y="379397"/>
+            <a:ext cx="5183188" cy="709393"/>
+          </a:xfrm>
+        </p:spPr>
+        <p:txBody>
+          <a:bodyPr>
+            <a:normAutofit/>
+          </a:bodyPr>
+          <a:lstStyle/>
+          <a:p>
+            <a:pPr marL="0" marR="0" lvl="0" indent="0" algn="l" defTabSz="914400" rtl="0" eaLnBrk="1" fontAlgn="auto" latinLnBrk="0" hangingPunct="1">
+              <a:lnSpc>
+                <a:spcPct val="120000"/>
+              </a:lnSpc>
+              <a:spcBef>
+                <a:spcPts val="1000"/>
+              </a:spcBef>
+              <a:spcAft>
+                <a:spcPts val="0"/>
+              </a:spcAft>
+              <a:buClrTx/>
+              <a:buSzTx/>
+              <a:buFont typeface="Arial" panose="020B0604020202020204" pitchFamily="34" charset="0"/>
+              <a:buNone/>
+              <a:tabLst/>
+              <a:defRPr/>
+            </a:pPr>
+            <a:r>
+              <a:rPr kumimoji="0" lang="en-US" sz="2800" b="0" i="0" u="none" strike="noStrike" kern="1200" cap="none" spc="0" normalizeH="0" baseline="0" noProof="0" dirty="0">
+                <a:ln>
+                  <a:noFill/>
+                </a:ln>
+                <a:solidFill>
+                  <a:srgbClr val="444742"/>
+                </a:solidFill>
+                <a:effectLst/>
+                <a:uLnTx/>
+                <a:uFillTx/>
+                <a:latin typeface="Univers Condensed Light"/>
+                <a:ea typeface="+mn-ea"/>
+                <a:cs typeface="+mn-cs"/>
+              </a:rPr>
+              <a:t>Layered Roads</a:t>
+            </a:r>
+          </a:p>
+        </p:txBody>
+      </p:sp>
+      <p:sp>
+        <p:nvSpPr>
+          <p:cNvPr id="6" name="Content Placeholder 5">
+            <a:extLst>
+              <a:ext uri="{FF2B5EF4-FFF2-40B4-BE49-F238E27FC236}">
+                <a16:creationId xmlns:a16="http://schemas.microsoft.com/office/drawing/2014/main" id="{455FD4A5-B60E-6DB4-1C59-CDDD2A588E39}"/>
+              </a:ext>
+            </a:extLst>
+          </p:cNvPr>
+          <p:cNvSpPr>
+            <a:spLocks noGrp="1"/>
+          </p:cNvSpPr>
+          <p:nvPr>
+            <p:ph sz="quarter" idx="4"/>
+          </p:nvPr>
+        </p:nvSpPr>
+        <p:spPr>
+          <a:xfrm>
+            <a:off x="6231402" y="1138171"/>
+            <a:ext cx="5183188" cy="3495254"/>
+          </a:xfrm>
+        </p:spPr>
+        <p:txBody>
+          <a:bodyPr>
+            <a:normAutofit/>
+          </a:bodyPr>
+          <a:lstStyle/>
+          <a:p>
+            <a:pPr marL="228600" marR="0" lvl="0" indent="-228600" algn="l" defTabSz="914400" rtl="0" eaLnBrk="1" fontAlgn="auto" latinLnBrk="0" hangingPunct="1">
+              <a:lnSpc>
+                <a:spcPct val="120000"/>
+              </a:lnSpc>
+              <a:spcBef>
+                <a:spcPts val="1000"/>
+              </a:spcBef>
+              <a:spcAft>
+                <a:spcPts val="0"/>
+              </a:spcAft>
+              <a:buClrTx/>
+              <a:buSzTx/>
+              <a:buFont typeface="Arial" panose="020B0604020202020204" pitchFamily="34" charset="0"/>
+              <a:buChar char="•"/>
+              <a:tabLst/>
+              <a:defRPr/>
+            </a:pPr>
+            <a:r>
+              <a:rPr kumimoji="0" lang="en-US" sz="2400" b="0" i="0" u="none" strike="noStrike" kern="1200" cap="none" spc="0" normalizeH="0" baseline="0" noProof="0" dirty="0">
+                <a:ln>
+                  <a:noFill/>
+                </a:ln>
+                <a:solidFill>
+                  <a:srgbClr val="444742"/>
+                </a:solidFill>
+                <a:effectLst/>
+                <a:uLnTx/>
+                <a:uFillTx/>
+                <a:latin typeface="Univers Condensed Light"/>
+                <a:ea typeface="+mn-ea"/>
+                <a:cs typeface="+mn-cs"/>
+              </a:rPr>
+              <a:t>Add </a:t>
+            </a:r>
+            <a:r>
+              <a:rPr lang="en-US" sz="2400" dirty="0">
+                <a:solidFill>
+                  <a:srgbClr val="444742"/>
+                </a:solidFill>
+                <a:latin typeface="Univers Condensed Light"/>
+              </a:rPr>
+              <a:t>Limited Elevation Control to Simulation</a:t>
+            </a:r>
+          </a:p>
+          <a:p>
+            <a:pPr lvl="1">
+              <a:spcBef>
+                <a:spcPts val="1000"/>
+              </a:spcBef>
+              <a:defRPr/>
+            </a:pPr>
+            <a:r>
+              <a:rPr lang="en-US" sz="2400" dirty="0">
+                <a:solidFill>
+                  <a:srgbClr val="444742"/>
+                </a:solidFill>
+                <a:latin typeface="Univers Condensed Light"/>
+              </a:rPr>
+              <a:t>Overpasses</a:t>
+            </a:r>
+          </a:p>
+          <a:p>
+            <a:pPr lvl="1">
+              <a:spcBef>
+                <a:spcPts val="1000"/>
+              </a:spcBef>
+              <a:defRPr/>
+            </a:pPr>
+            <a:r>
+              <a:rPr lang="en-US" sz="2400" dirty="0">
+                <a:solidFill>
+                  <a:srgbClr val="444742"/>
+                </a:solidFill>
+                <a:latin typeface="Univers Condensed Light"/>
+              </a:rPr>
+              <a:t>Underpasses</a:t>
+            </a:r>
+          </a:p>
+          <a:p>
+            <a:pPr marL="228600" marR="0" lvl="0" indent="-228600" algn="l" defTabSz="914400" rtl="0" eaLnBrk="1" fontAlgn="auto" latinLnBrk="0" hangingPunct="1">
+              <a:lnSpc>
+                <a:spcPct val="120000"/>
+              </a:lnSpc>
+              <a:spcBef>
+                <a:spcPts val="1000"/>
+              </a:spcBef>
+              <a:spcAft>
+                <a:spcPts val="0"/>
+              </a:spcAft>
+              <a:buClrTx/>
+              <a:buSzTx/>
+              <a:buFont typeface="Arial" panose="020B0604020202020204" pitchFamily="34" charset="0"/>
+              <a:buChar char="•"/>
+              <a:tabLst/>
+              <a:defRPr/>
+            </a:pPr>
+            <a:r>
+              <a:rPr kumimoji="0" lang="en-US" sz="2400" b="0" i="0" u="none" strike="noStrike" kern="1200" cap="none" spc="0" normalizeH="0" baseline="0" noProof="0" dirty="0">
+                <a:ln>
+                  <a:noFill/>
+                </a:ln>
+                <a:solidFill>
+                  <a:srgbClr val="444742"/>
+                </a:solidFill>
+                <a:effectLst/>
+                <a:uLnTx/>
+                <a:uFillTx/>
+                <a:latin typeface="Univers Condensed Light"/>
+                <a:ea typeface="+mn-ea"/>
+                <a:cs typeface="+mn-cs"/>
+              </a:rPr>
+              <a:t>Useful for</a:t>
+            </a:r>
+            <a:r>
+              <a:rPr lang="en-US" sz="2400" dirty="0">
+                <a:solidFill>
+                  <a:srgbClr val="444742"/>
+                </a:solidFill>
+                <a:latin typeface="Univers Condensed Light"/>
+              </a:rPr>
+              <a:t> Highway Intersections</a:t>
+            </a:r>
+          </a:p>
+          <a:p>
+            <a:pPr lvl="1">
+              <a:spcBef>
+                <a:spcPts val="1000"/>
+              </a:spcBef>
+              <a:defRPr/>
+            </a:pPr>
+            <a:r>
+              <a:rPr kumimoji="0" lang="en-US" sz="2400" b="0" i="0" u="none" strike="noStrike" kern="1200" cap="none" spc="0" normalizeH="0" baseline="0" noProof="0" dirty="0">
+                <a:ln>
+                  <a:noFill/>
+                </a:ln>
+                <a:solidFill>
+                  <a:srgbClr val="444742"/>
+                </a:solidFill>
+                <a:effectLst/>
+                <a:uLnTx/>
+                <a:uFillTx/>
+                <a:latin typeface="Univers Condensed Light"/>
+                <a:ea typeface="+mn-ea"/>
+                <a:cs typeface="+mn-cs"/>
+              </a:rPr>
+              <a:t>Dog</a:t>
+            </a:r>
+            <a:r>
+              <a:rPr lang="en-US" sz="2400" dirty="0">
+                <a:solidFill>
+                  <a:srgbClr val="444742"/>
+                </a:solidFill>
+                <a:latin typeface="Univers Condensed Light"/>
+              </a:rPr>
+              <a:t>bone Interchange</a:t>
+            </a:r>
+            <a:endParaRPr kumimoji="0" lang="en-US" sz="2400" b="0" i="0" u="none" strike="noStrike" kern="1200" cap="none" spc="0" normalizeH="0" baseline="0" noProof="0" dirty="0">
+              <a:ln>
+                <a:noFill/>
+              </a:ln>
+              <a:solidFill>
+                <a:srgbClr val="444742"/>
+              </a:solidFill>
+              <a:effectLst/>
+              <a:uLnTx/>
+              <a:uFillTx/>
+              <a:latin typeface="Univers Condensed Light"/>
+              <a:ea typeface="+mn-ea"/>
+              <a:cs typeface="+mn-cs"/>
+            </a:endParaRPr>
+          </a:p>
+        </p:txBody>
+      </p:sp>
+      <p:pic>
+        <p:nvPicPr>
+          <p:cNvPr id="7" name="Picture 6" descr="Dogbone interchange. : r/CitiesSkylines">
+            <a:extLst>
+              <a:ext uri="{FF2B5EF4-FFF2-40B4-BE49-F238E27FC236}">
+                <a16:creationId xmlns:a16="http://schemas.microsoft.com/office/drawing/2014/main" id="{C5F3410A-C7BA-81B4-DEE1-41880DF9F8DC}"/>
+              </a:ext>
+            </a:extLst>
+          </p:cNvPr>
+          <p:cNvPicPr>
+            <a:picLocks noChangeAspect="1"/>
+          </p:cNvPicPr>
+          <p:nvPr/>
+        </p:nvPicPr>
+        <p:blipFill>
+          <a:blip r:embed="rId2"/>
+          <a:srcRect l="22640" t="14930" r="6957" b="28671"/>
+          <a:stretch>
+            <a:fillRect/>
+          </a:stretch>
+        </p:blipFill>
+        <p:spPr>
+          <a:xfrm>
+            <a:off x="6489906" y="4340888"/>
+            <a:ext cx="3879993" cy="1748413"/>
+          </a:xfrm>
+          <a:prstGeom prst="rect">
+            <a:avLst/>
+          </a:prstGeom>
+        </p:spPr>
+      </p:pic>
     </p:spTree>
     <p:extLst>
       <p:ext uri="{BB962C8B-B14F-4D97-AF65-F5344CB8AC3E}">

</xml_diff>

<commit_message>
Stretch Goals Part 2 Slide Completed for Design Suggestions and Advanced Pedestrian Support
</commit_message>
<xml_diff>
--- a/Traffic Sim.pptx
+++ b/Traffic Sim.pptx
@@ -7,6 +7,7 @@
   <p:sldIdLst>
     <p:sldId id="256" r:id="rId2"/>
     <p:sldId id="257" r:id="rId3"/>
+    <p:sldId id="258" r:id="rId4"/>
   </p:sldIdLst>
   <p:sldSz cx="12192000" cy="6858000"/>
   <p:notesSz cx="6858000" cy="9144000"/>
@@ -10062,7 +10063,7 @@
           <a:p>
             <a:r>
               <a:rPr lang="en-US" sz="4000" dirty="0"/>
-              <a:t>Stretch Goals</a:t>
+              <a:t>Stretch Goals: Part I</a:t>
             </a:r>
           </a:p>
         </p:txBody>
@@ -10507,6 +10508,375 @@
     <p:extLst>
       <p:ext uri="{BB962C8B-B14F-4D97-AF65-F5344CB8AC3E}">
         <p14:creationId xmlns:p14="http://schemas.microsoft.com/office/powerpoint/2010/main" val="2043908860"/>
+      </p:ext>
+    </p:extLst>
+  </p:cSld>
+  <p:clrMapOvr>
+    <a:masterClrMapping/>
+  </p:clrMapOvr>
+</p:sld>
+</file>
+
+<file path=ppt/slides/slide3.xml><?xml version="1.0" encoding="utf-8"?>
+<p:sld xmlns:a="http://schemas.openxmlformats.org/drawingml/2006/main" xmlns:r="http://schemas.openxmlformats.org/officeDocument/2006/relationships" xmlns:p="http://schemas.openxmlformats.org/presentationml/2006/main">
+  <p:cSld>
+    <p:spTree>
+      <p:nvGrpSpPr>
+        <p:cNvPr id="1" name="">
+          <a:extLst>
+            <a:ext uri="{FF2B5EF4-FFF2-40B4-BE49-F238E27FC236}">
+              <a16:creationId xmlns:a16="http://schemas.microsoft.com/office/drawing/2014/main" id="{AD79BFF0-58BA-59B2-382E-27F20F46E56E}"/>
+            </a:ext>
+          </a:extLst>
+        </p:cNvPr>
+        <p:cNvGrpSpPr/>
+        <p:nvPr/>
+      </p:nvGrpSpPr>
+      <p:grpSpPr>
+        <a:xfrm>
+          <a:off x="0" y="0"/>
+          <a:ext cx="0" cy="0"/>
+          <a:chOff x="0" y="0"/>
+          <a:chExt cx="0" cy="0"/>
+        </a:xfrm>
+      </p:grpSpPr>
+      <p:sp>
+        <p:nvSpPr>
+          <p:cNvPr id="2" name="Title 1">
+            <a:extLst>
+              <a:ext uri="{FF2B5EF4-FFF2-40B4-BE49-F238E27FC236}">
+                <a16:creationId xmlns:a16="http://schemas.microsoft.com/office/drawing/2014/main" id="{AB2C87D0-18DD-190D-8277-5E27B3276417}"/>
+              </a:ext>
+            </a:extLst>
+          </p:cNvPr>
+          <p:cNvSpPr>
+            <a:spLocks noGrp="1"/>
+          </p:cNvSpPr>
+          <p:nvPr>
+            <p:ph type="title"/>
+          </p:nvPr>
+        </p:nvSpPr>
+        <p:spPr>
+          <a:xfrm>
+            <a:off x="605431" y="274926"/>
+            <a:ext cx="5355169" cy="1069848"/>
+          </a:xfrm>
+        </p:spPr>
+        <p:txBody>
+          <a:bodyPr>
+            <a:normAutofit/>
+          </a:bodyPr>
+          <a:lstStyle/>
+          <a:p>
+            <a:r>
+              <a:rPr lang="en-US" sz="4000" dirty="0"/>
+              <a:t>Stretch Goals: Part II</a:t>
+            </a:r>
+          </a:p>
+        </p:txBody>
+      </p:sp>
+      <p:sp>
+        <p:nvSpPr>
+          <p:cNvPr id="4" name="Text Placeholder 3">
+            <a:extLst>
+              <a:ext uri="{FF2B5EF4-FFF2-40B4-BE49-F238E27FC236}">
+                <a16:creationId xmlns:a16="http://schemas.microsoft.com/office/drawing/2014/main" id="{DEFF4969-79BF-C3EA-FE54-382BB3EF7853}"/>
+              </a:ext>
+            </a:extLst>
+          </p:cNvPr>
+          <p:cNvSpPr>
+            <a:spLocks noGrp="1"/>
+          </p:cNvSpPr>
+          <p:nvPr>
+            <p:ph type="body" idx="1"/>
+          </p:nvPr>
+        </p:nvSpPr>
+        <p:spPr>
+          <a:xfrm>
+            <a:off x="605431" y="1387408"/>
+            <a:ext cx="5157787" cy="709394"/>
+          </a:xfrm>
+        </p:spPr>
+        <p:txBody>
+          <a:bodyPr>
+            <a:normAutofit/>
+          </a:bodyPr>
+          <a:lstStyle/>
+          <a:p>
+            <a:pPr marL="0" marR="0" lvl="0" indent="0" algn="l" defTabSz="914400" rtl="0" eaLnBrk="1" fontAlgn="auto" latinLnBrk="0" hangingPunct="1">
+              <a:lnSpc>
+                <a:spcPct val="120000"/>
+              </a:lnSpc>
+              <a:spcBef>
+                <a:spcPts val="1000"/>
+              </a:spcBef>
+              <a:spcAft>
+                <a:spcPts val="0"/>
+              </a:spcAft>
+              <a:buClrTx/>
+              <a:buSzTx/>
+              <a:buFont typeface="Arial" panose="020B0604020202020204" pitchFamily="34" charset="0"/>
+              <a:buNone/>
+              <a:tabLst/>
+              <a:defRPr/>
+            </a:pPr>
+            <a:r>
+              <a:rPr kumimoji="0" lang="en-US" sz="2800" b="0" i="0" u="none" strike="noStrike" kern="1200" cap="none" spc="0" normalizeH="0" baseline="0" noProof="0" dirty="0">
+                <a:ln>
+                  <a:noFill/>
+                </a:ln>
+                <a:solidFill>
+                  <a:srgbClr val="444742"/>
+                </a:solidFill>
+                <a:effectLst/>
+                <a:uLnTx/>
+                <a:uFillTx/>
+                <a:latin typeface="Univers Condensed Light"/>
+                <a:ea typeface="+mn-ea"/>
+                <a:cs typeface="+mn-cs"/>
+              </a:rPr>
+              <a:t>Design Suggestions</a:t>
+            </a:r>
+          </a:p>
+        </p:txBody>
+      </p:sp>
+      <p:sp>
+        <p:nvSpPr>
+          <p:cNvPr id="3" name="Content Placeholder 2">
+            <a:extLst>
+              <a:ext uri="{FF2B5EF4-FFF2-40B4-BE49-F238E27FC236}">
+                <a16:creationId xmlns:a16="http://schemas.microsoft.com/office/drawing/2014/main" id="{070FC9F8-DE2A-C4CE-570F-9146F3E802C7}"/>
+              </a:ext>
+            </a:extLst>
+          </p:cNvPr>
+          <p:cNvSpPr>
+            <a:spLocks noGrp="1"/>
+          </p:cNvSpPr>
+          <p:nvPr>
+            <p:ph sz="half" idx="2"/>
+          </p:nvPr>
+        </p:nvSpPr>
+        <p:spPr>
+          <a:xfrm>
+            <a:off x="621858" y="2139436"/>
+            <a:ext cx="5157787" cy="3495253"/>
+          </a:xfrm>
+        </p:spPr>
+        <p:txBody>
+          <a:bodyPr>
+            <a:normAutofit/>
+          </a:bodyPr>
+          <a:lstStyle/>
+          <a:p>
+            <a:r>
+              <a:rPr lang="en-US" sz="2400" dirty="0"/>
+              <a:t>Algorithm Testing Common Intersections</a:t>
+            </a:r>
+          </a:p>
+          <a:p>
+            <a:pPr lvl="1"/>
+            <a:r>
+              <a:rPr lang="en-US" sz="2400" dirty="0"/>
+              <a:t>Intersection Types Predetermined</a:t>
+            </a:r>
+          </a:p>
+          <a:p>
+            <a:r>
+              <a:rPr lang="en-US" sz="2400" dirty="0"/>
+              <a:t>Uses Simulation Feature</a:t>
+            </a:r>
+          </a:p>
+          <a:p>
+            <a:r>
+              <a:rPr lang="en-US" sz="2400" dirty="0"/>
+              <a:t>Returns Best Resulting Intersection</a:t>
+            </a:r>
+          </a:p>
+        </p:txBody>
+      </p:sp>
+      <p:sp>
+        <p:nvSpPr>
+          <p:cNvPr id="5" name="Text Placeholder 4">
+            <a:extLst>
+              <a:ext uri="{FF2B5EF4-FFF2-40B4-BE49-F238E27FC236}">
+                <a16:creationId xmlns:a16="http://schemas.microsoft.com/office/drawing/2014/main" id="{6E560669-2257-4D6E-BB1D-747CDCC23DBC}"/>
+              </a:ext>
+            </a:extLst>
+          </p:cNvPr>
+          <p:cNvSpPr>
+            <a:spLocks noGrp="1"/>
+          </p:cNvSpPr>
+          <p:nvPr>
+            <p:ph type="body" sz="quarter" idx="3"/>
+          </p:nvPr>
+        </p:nvSpPr>
+        <p:spPr>
+          <a:xfrm>
+            <a:off x="6231402" y="1387408"/>
+            <a:ext cx="5183188" cy="709393"/>
+          </a:xfrm>
+        </p:spPr>
+        <p:txBody>
+          <a:bodyPr>
+            <a:normAutofit/>
+          </a:bodyPr>
+          <a:lstStyle/>
+          <a:p>
+            <a:pPr marL="0" marR="0" lvl="0" indent="0" algn="l" defTabSz="914400" rtl="0" eaLnBrk="1" fontAlgn="auto" latinLnBrk="0" hangingPunct="1">
+              <a:lnSpc>
+                <a:spcPct val="120000"/>
+              </a:lnSpc>
+              <a:spcBef>
+                <a:spcPts val="1000"/>
+              </a:spcBef>
+              <a:spcAft>
+                <a:spcPts val="0"/>
+              </a:spcAft>
+              <a:buClrTx/>
+              <a:buSzTx/>
+              <a:buFont typeface="Arial" panose="020B0604020202020204" pitchFamily="34" charset="0"/>
+              <a:buNone/>
+              <a:tabLst/>
+              <a:defRPr/>
+            </a:pPr>
+            <a:r>
+              <a:rPr kumimoji="0" lang="en-US" sz="2800" b="0" i="0" u="none" strike="noStrike" kern="1200" cap="none" spc="0" normalizeH="0" baseline="0" noProof="0" dirty="0">
+                <a:ln>
+                  <a:noFill/>
+                </a:ln>
+                <a:solidFill>
+                  <a:srgbClr val="444742"/>
+                </a:solidFill>
+                <a:effectLst/>
+                <a:uLnTx/>
+                <a:uFillTx/>
+                <a:latin typeface="Univers Condensed Light"/>
+                <a:ea typeface="+mn-ea"/>
+                <a:cs typeface="+mn-cs"/>
+              </a:rPr>
+              <a:t>Advanced Pedestrian Support</a:t>
+            </a:r>
+          </a:p>
+        </p:txBody>
+      </p:sp>
+      <p:sp>
+        <p:nvSpPr>
+          <p:cNvPr id="6" name="Content Placeholder 5">
+            <a:extLst>
+              <a:ext uri="{FF2B5EF4-FFF2-40B4-BE49-F238E27FC236}">
+                <a16:creationId xmlns:a16="http://schemas.microsoft.com/office/drawing/2014/main" id="{63ABAEC1-F057-6991-B094-74827E10D0B0}"/>
+              </a:ext>
+            </a:extLst>
+          </p:cNvPr>
+          <p:cNvSpPr>
+            <a:spLocks noGrp="1"/>
+          </p:cNvSpPr>
+          <p:nvPr>
+            <p:ph sz="quarter" idx="4"/>
+          </p:nvPr>
+        </p:nvSpPr>
+        <p:spPr>
+          <a:xfrm>
+            <a:off x="6231402" y="2139436"/>
+            <a:ext cx="5183188" cy="3495254"/>
+          </a:xfrm>
+        </p:spPr>
+        <p:txBody>
+          <a:bodyPr>
+            <a:normAutofit/>
+          </a:bodyPr>
+          <a:lstStyle/>
+          <a:p>
+            <a:pPr>
+              <a:defRPr/>
+            </a:pPr>
+            <a:r>
+              <a:rPr lang="en-US" sz="2400" dirty="0">
+                <a:solidFill>
+                  <a:srgbClr val="444742"/>
+                </a:solidFill>
+                <a:latin typeface="Univers Condensed Light"/>
+              </a:rPr>
+              <a:t>More Than One Type of Actor</a:t>
+            </a:r>
+          </a:p>
+          <a:p>
+            <a:pPr>
+              <a:defRPr/>
+            </a:pPr>
+            <a:r>
+              <a:rPr lang="en-US" sz="2400" dirty="0">
+                <a:solidFill>
+                  <a:srgbClr val="444742"/>
+                </a:solidFill>
+                <a:latin typeface="Univers Condensed Light"/>
+              </a:rPr>
+              <a:t>Differing Behavior</a:t>
+            </a:r>
+            <a:endParaRPr lang="en-US" sz="2800" dirty="0">
+              <a:solidFill>
+                <a:srgbClr val="444742"/>
+              </a:solidFill>
+              <a:latin typeface="Univers Condensed Light"/>
+            </a:endParaRPr>
+          </a:p>
+          <a:p>
+            <a:pPr lvl="1">
+              <a:spcBef>
+                <a:spcPts val="1000"/>
+              </a:spcBef>
+              <a:defRPr/>
+            </a:pPr>
+            <a:r>
+              <a:rPr lang="en-US" sz="2400" dirty="0">
+                <a:solidFill>
+                  <a:srgbClr val="444742"/>
+                </a:solidFill>
+                <a:latin typeface="Univers Condensed Light"/>
+              </a:rPr>
+              <a:t>Speed</a:t>
+            </a:r>
+          </a:p>
+          <a:p>
+            <a:pPr lvl="1">
+              <a:spcBef>
+                <a:spcPts val="1000"/>
+              </a:spcBef>
+              <a:defRPr/>
+            </a:pPr>
+            <a:r>
+              <a:rPr lang="en-US" sz="2400" dirty="0">
+                <a:solidFill>
+                  <a:srgbClr val="444742"/>
+                </a:solidFill>
+                <a:latin typeface="Univers Condensed Light"/>
+              </a:rPr>
+              <a:t>Awareness</a:t>
+            </a:r>
+          </a:p>
+          <a:p>
+            <a:pPr lvl="1">
+              <a:spcBef>
+                <a:spcPts val="1000"/>
+              </a:spcBef>
+              <a:defRPr/>
+            </a:pPr>
+            <a:r>
+              <a:rPr lang="en-US" sz="2400" dirty="0">
+                <a:solidFill>
+                  <a:srgbClr val="444742"/>
+                </a:solidFill>
+                <a:latin typeface="Univers Condensed Light"/>
+              </a:rPr>
+              <a:t>Caution</a:t>
+            </a:r>
+          </a:p>
+        </p:txBody>
+      </p:sp>
+    </p:spTree>
+    <p:extLst>
+      <p:ext uri="{BB962C8B-B14F-4D97-AF65-F5344CB8AC3E}">
+        <p14:creationId xmlns:p14="http://schemas.microsoft.com/office/powerpoint/2010/main" val="1572061499"/>
       </p:ext>
     </p:extLst>
   </p:cSld>

</xml_diff>

<commit_message>
Added Slides from Zane_Dollarhide_Project_Proposal_Draft branch to main
</commit_message>
<xml_diff>
--- a/Traffic Sim.pptx
+++ b/Traffic Sim.pptx
@@ -7,6 +7,8 @@
   <p:sldIdLst>
     <p:sldId id="256" r:id="rId2"/>
     <p:sldId id="257" r:id="rId3"/>
+    <p:sldId id="258" r:id="rId4"/>
+    <p:sldId id="259" r:id="rId5"/>
   </p:sldIdLst>
   <p:sldSz cx="12192000" cy="6858000"/>
   <p:notesSz cx="6858000" cy="9144000"/>
@@ -105,6 +107,11 @@
       </a:defRPr>
     </a:lvl9pPr>
   </p:defaultTextStyle>
+  <p:extLst>
+    <p:ext uri="{EFAFB233-063F-42B5-8137-9DF3F51BA10A}">
+      <p15:sldGuideLst xmlns:p15="http://schemas.microsoft.com/office/powerpoint/2012/main"/>
+    </p:ext>
+  </p:extLst>
 </p:presentation>
 </file>
 
@@ -527,7 +534,7 @@
           <a:p>
             <a:fld id="{D4F53BF9-51A7-479A-9F82-F12307D0B401}" type="datetimeFigureOut">
               <a:rPr lang="en-US" smtClean="0"/>
-              <a:t>10/27/2026</a:t>
+              <a:t>10/28/2026</a:t>
             </a:fld>
             <a:endParaRPr lang="en-US"/>
           </a:p>
@@ -852,7 +859,7 @@
           <a:p>
             <a:fld id="{D4F53BF9-51A7-479A-9F82-F12307D0B401}" type="datetimeFigureOut">
               <a:rPr lang="en-US" smtClean="0"/>
-              <a:t>10/27/2026</a:t>
+              <a:t>10/28/2026</a:t>
             </a:fld>
             <a:endParaRPr lang="en-US"/>
           </a:p>
@@ -1111,7 +1118,7 @@
           <a:p>
             <a:fld id="{D4F53BF9-51A7-479A-9F82-F12307D0B401}" type="datetimeFigureOut">
               <a:rPr lang="en-US" smtClean="0"/>
-              <a:t>10/27/2026</a:t>
+              <a:t>10/28/2026</a:t>
             </a:fld>
             <a:endParaRPr lang="en-US"/>
           </a:p>
@@ -1376,7 +1383,7 @@
           <a:p>
             <a:fld id="{D4F53BF9-51A7-479A-9F82-F12307D0B401}" type="datetimeFigureOut">
               <a:rPr lang="en-US" smtClean="0"/>
-              <a:t>10/27/2026</a:t>
+              <a:t>10/28/2026</a:t>
             </a:fld>
             <a:endParaRPr lang="en-US"/>
           </a:p>
@@ -1646,7 +1653,7 @@
           <a:p>
             <a:fld id="{D4F53BF9-51A7-479A-9F82-F12307D0B401}" type="datetimeFigureOut">
               <a:rPr lang="en-US" smtClean="0"/>
-              <a:t>10/27/2026</a:t>
+              <a:t>10/28/2026</a:t>
             </a:fld>
             <a:endParaRPr lang="en-US"/>
           </a:p>
@@ -1923,7 +1930,7 @@
           <a:p>
             <a:fld id="{D4F53BF9-51A7-479A-9F82-F12307D0B401}" type="datetimeFigureOut">
               <a:rPr lang="en-US" smtClean="0"/>
-              <a:t>10/27/2026</a:t>
+              <a:t>10/28/2026</a:t>
             </a:fld>
             <a:endParaRPr lang="en-US"/>
           </a:p>
@@ -2287,7 +2294,7 @@
           <a:p>
             <a:fld id="{D4F53BF9-51A7-479A-9F82-F12307D0B401}" type="datetimeFigureOut">
               <a:rPr lang="en-US" smtClean="0"/>
-              <a:t>10/27/2026</a:t>
+              <a:t>10/28/2026</a:t>
             </a:fld>
             <a:endParaRPr lang="en-US"/>
           </a:p>
@@ -2582,7 +2589,7 @@
           <a:p>
             <a:fld id="{D4F53BF9-51A7-479A-9F82-F12307D0B401}" type="datetimeFigureOut">
               <a:rPr lang="en-US" smtClean="0"/>
-              <a:t>10/27/2026</a:t>
+              <a:t>10/28/2026</a:t>
             </a:fld>
             <a:endParaRPr lang="en-US"/>
           </a:p>
@@ -2857,7 +2864,7 @@
           <a:p>
             <a:fld id="{D4F53BF9-51A7-479A-9F82-F12307D0B401}" type="datetimeFigureOut">
               <a:rPr lang="en-US" smtClean="0"/>
-              <a:t>10/27/2026</a:t>
+              <a:t>10/28/2026</a:t>
             </a:fld>
             <a:endParaRPr lang="en-US"/>
           </a:p>
@@ -3184,7 +3191,7 @@
           <a:p>
             <a:fld id="{D4F53BF9-51A7-479A-9F82-F12307D0B401}" type="datetimeFigureOut">
               <a:rPr lang="en-US" smtClean="0"/>
-              <a:t>10/27/2026</a:t>
+              <a:t>10/28/2026</a:t>
             </a:fld>
             <a:endParaRPr lang="en-US"/>
           </a:p>
@@ -3486,7 +3493,7 @@
           <a:p>
             <a:fld id="{D4F53BF9-51A7-479A-9F82-F12307D0B401}" type="datetimeFigureOut">
               <a:rPr lang="en-US" smtClean="0"/>
-              <a:t>10/27/2026</a:t>
+              <a:t>10/28/2026</a:t>
             </a:fld>
             <a:endParaRPr lang="en-US"/>
           </a:p>
@@ -3758,7 +3765,7 @@
           <a:p>
             <a:fld id="{D4F53BF9-51A7-479A-9F82-F12307D0B401}" type="datetimeFigureOut">
               <a:rPr lang="en-US" smtClean="0"/>
-              <a:t>10/27/2026</a:t>
+              <a:t>10/28/2026</a:t>
             </a:fld>
             <a:endParaRPr lang="en-US"/>
           </a:p>
@@ -4157,7 +4164,7 @@
           <a:p>
             <a:fld id="{D4F53BF9-51A7-479A-9F82-F12307D0B401}" type="datetimeFigureOut">
               <a:rPr lang="en-US" smtClean="0"/>
-              <a:t>10/27/2026</a:t>
+              <a:t>10/28/2026</a:t>
             </a:fld>
             <a:endParaRPr lang="en-US"/>
           </a:p>
@@ -4599,7 +4606,7 @@
           <a:p>
             <a:fld id="{D4F53BF9-51A7-479A-9F82-F12307D0B401}" type="datetimeFigureOut">
               <a:rPr lang="en-US" smtClean="0"/>
-              <a:t>10/27/2026</a:t>
+              <a:t>10/28/2026</a:t>
             </a:fld>
             <a:endParaRPr lang="en-US"/>
           </a:p>
@@ -4889,7 +4896,7 @@
           <a:p>
             <a:fld id="{D4F53BF9-51A7-479A-9F82-F12307D0B401}" type="datetimeFigureOut">
               <a:rPr lang="en-US" smtClean="0"/>
-              <a:t>10/27/2026</a:t>
+              <a:t>10/28/2026</a:t>
             </a:fld>
             <a:endParaRPr lang="en-US"/>
           </a:p>
@@ -5309,7 +5316,7 @@
           <a:p>
             <a:fld id="{D4F53BF9-51A7-479A-9F82-F12307D0B401}" type="datetimeFigureOut">
               <a:rPr lang="en-US" smtClean="0"/>
-              <a:t>10/27/2026</a:t>
+              <a:t>10/28/2026</a:t>
             </a:fld>
             <a:endParaRPr lang="en-US"/>
           </a:p>
@@ -5457,7 +5464,7 @@
           <a:p>
             <a:fld id="{D4F53BF9-51A7-479A-9F82-F12307D0B401}" type="datetimeFigureOut">
               <a:rPr lang="en-US" smtClean="0"/>
-              <a:t>10/27/2026</a:t>
+              <a:t>10/28/2026</a:t>
             </a:fld>
             <a:endParaRPr lang="en-US"/>
           </a:p>
@@ -5570,7 +5577,7 @@
           <a:p>
             <a:fld id="{D4F53BF9-51A7-479A-9F82-F12307D0B401}" type="datetimeFigureOut">
               <a:rPr lang="en-US" smtClean="0"/>
-              <a:t>10/27/2026</a:t>
+              <a:t>10/28/2026</a:t>
             </a:fld>
             <a:endParaRPr lang="en-US"/>
           </a:p>
@@ -5978,7 +5985,7 @@
           <a:p>
             <a:fld id="{D4F53BF9-51A7-479A-9F82-F12307D0B401}" type="datetimeFigureOut">
               <a:rPr lang="en-US" smtClean="0"/>
-              <a:t>10/27/2026</a:t>
+              <a:t>10/28/2026</a:t>
             </a:fld>
             <a:endParaRPr lang="en-US"/>
           </a:p>
@@ -6427,7 +6434,7 @@
           <a:p>
             <a:fld id="{D4F53BF9-51A7-479A-9F82-F12307D0B401}" type="datetimeFigureOut">
               <a:rPr lang="en-US" smtClean="0"/>
-              <a:t>10/27/2026</a:t>
+              <a:t>10/28/2026</a:t>
             </a:fld>
             <a:endParaRPr lang="en-US"/>
           </a:p>
@@ -6845,7 +6852,7 @@
           <a:p>
             <a:fld id="{D4F53BF9-51A7-479A-9F82-F12307D0B401}" type="datetimeFigureOut">
               <a:rPr lang="en-US" smtClean="0"/>
-              <a:t>10/27/2026</a:t>
+              <a:t>10/28/2026</a:t>
             </a:fld>
             <a:endParaRPr lang="en-US"/>
           </a:p>
@@ -7209,7 +7216,7 @@
           <a:p>
             <a:fld id="{D4F53BF9-51A7-479A-9F82-F12307D0B401}" type="datetimeFigureOut">
               <a:rPr lang="en-US" smtClean="0"/>
-              <a:t>10/27/2026</a:t>
+              <a:t>10/28/2026</a:t>
             </a:fld>
             <a:endParaRPr lang="en-US"/>
           </a:p>
@@ -7507,7 +7514,7 @@
           <a:p>
             <a:fld id="{D4F53BF9-51A7-479A-9F82-F12307D0B401}" type="datetimeFigureOut">
               <a:rPr lang="en-US" smtClean="0"/>
-              <a:t>10/27/2026</a:t>
+              <a:t>10/28/2026</a:t>
             </a:fld>
             <a:endParaRPr lang="en-US"/>
           </a:p>
@@ -7978,7 +7985,7 @@
           <a:p>
             <a:fld id="{D4F53BF9-51A7-479A-9F82-F12307D0B401}" type="datetimeFigureOut">
               <a:rPr lang="en-US" smtClean="0"/>
-              <a:t>10/27/2026</a:t>
+              <a:t>10/28/2026</a:t>
             </a:fld>
             <a:endParaRPr lang="en-US"/>
           </a:p>
@@ -8442,7 +8449,7 @@
           <a:p>
             <a:fld id="{D4F53BF9-51A7-479A-9F82-F12307D0B401}" type="datetimeFigureOut">
               <a:rPr lang="en-US" smtClean="0"/>
-              <a:t>10/27/2026</a:t>
+              <a:t>10/28/2026</a:t>
             </a:fld>
             <a:endParaRPr lang="en-US"/>
           </a:p>
@@ -8712,7 +8719,7 @@
           <a:p>
             <a:fld id="{D4F53BF9-51A7-479A-9F82-F12307D0B401}" type="datetimeFigureOut">
               <a:rPr lang="en-US" smtClean="0"/>
-              <a:t>10/27/2026</a:t>
+              <a:t>10/28/2026</a:t>
             </a:fld>
             <a:endParaRPr lang="en-US"/>
           </a:p>
@@ -8931,7 +8938,7 @@
           <a:p>
             <a:fld id="{D4F53BF9-51A7-479A-9F82-F12307D0B401}" type="datetimeFigureOut">
               <a:rPr lang="en-US" smtClean="0"/>
-              <a:t>10/27/2026</a:t>
+              <a:t>10/28/2026</a:t>
             </a:fld>
             <a:endParaRPr lang="en-US"/>
           </a:p>
@@ -9245,7 +9252,7 @@
           <a:p>
             <a:fld id="{D4F53BF9-51A7-479A-9F82-F12307D0B401}" type="datetimeFigureOut">
               <a:rPr lang="en-US" smtClean="0"/>
-              <a:t>10/27/2026</a:t>
+              <a:t>10/28/2026</a:t>
             </a:fld>
             <a:endParaRPr lang="en-US"/>
           </a:p>
@@ -10113,6 +10120,876 @@
 </p:sld>
 </file>
 
+<file path=ppt/slides/slide3.xml><?xml version="1.0" encoding="utf-8"?>
+<p:sld xmlns:a="http://schemas.openxmlformats.org/drawingml/2006/main" xmlns:r="http://schemas.openxmlformats.org/officeDocument/2006/relationships" xmlns:p="http://schemas.openxmlformats.org/presentationml/2006/main">
+  <p:cSld>
+    <p:spTree>
+      <p:nvGrpSpPr>
+        <p:cNvPr id="1" name=""/>
+        <p:cNvGrpSpPr/>
+        <p:nvPr/>
+      </p:nvGrpSpPr>
+      <p:grpSpPr>
+        <a:xfrm>
+          <a:off x="0" y="0"/>
+          <a:ext cx="0" cy="0"/>
+          <a:chOff x="0" y="0"/>
+          <a:chExt cx="0" cy="0"/>
+        </a:xfrm>
+      </p:grpSpPr>
+      <p:sp>
+        <p:nvSpPr>
+          <p:cNvPr id="2" name="Title 1">
+            <a:extLst>
+              <a:ext uri="{FF2B5EF4-FFF2-40B4-BE49-F238E27FC236}">
+                <a16:creationId xmlns:a16="http://schemas.microsoft.com/office/drawing/2014/main" id="{017A6928-A1FD-AFE4-7BFB-C26DA00157E2}"/>
+              </a:ext>
+            </a:extLst>
+          </p:cNvPr>
+          <p:cNvSpPr>
+            <a:spLocks noGrp="1"/>
+          </p:cNvSpPr>
+          <p:nvPr>
+            <p:ph type="title"/>
+          </p:nvPr>
+        </p:nvSpPr>
+        <p:spPr>
+          <a:xfrm>
+            <a:off x="605431" y="274926"/>
+            <a:ext cx="5355169" cy="1069848"/>
+          </a:xfrm>
+        </p:spPr>
+        <p:txBody>
+          <a:bodyPr>
+            <a:normAutofit/>
+          </a:bodyPr>
+          <a:lstStyle/>
+          <a:p>
+            <a:r>
+              <a:rPr lang="en-US" sz="4000" dirty="0"/>
+              <a:t>Stretch Goals: Part I</a:t>
+            </a:r>
+          </a:p>
+        </p:txBody>
+      </p:sp>
+      <p:sp>
+        <p:nvSpPr>
+          <p:cNvPr id="4" name="Text Placeholder 3">
+            <a:extLst>
+              <a:ext uri="{FF2B5EF4-FFF2-40B4-BE49-F238E27FC236}">
+                <a16:creationId xmlns:a16="http://schemas.microsoft.com/office/drawing/2014/main" id="{05641E9C-7073-207B-41C5-A5A94E56E0B1}"/>
+              </a:ext>
+            </a:extLst>
+          </p:cNvPr>
+          <p:cNvSpPr>
+            <a:spLocks noGrp="1"/>
+          </p:cNvSpPr>
+          <p:nvPr>
+            <p:ph type="body" idx="1"/>
+          </p:nvPr>
+        </p:nvSpPr>
+        <p:spPr>
+          <a:xfrm>
+            <a:off x="605431" y="1387408"/>
+            <a:ext cx="5157787" cy="709394"/>
+          </a:xfrm>
+        </p:spPr>
+        <p:txBody>
+          <a:bodyPr>
+            <a:normAutofit/>
+          </a:bodyPr>
+          <a:lstStyle/>
+          <a:p>
+            <a:pPr marL="0" marR="0" lvl="0" indent="0" algn="l" defTabSz="914400" rtl="0" eaLnBrk="1" fontAlgn="auto" latinLnBrk="0" hangingPunct="1">
+              <a:lnSpc>
+                <a:spcPct val="120000"/>
+              </a:lnSpc>
+              <a:spcBef>
+                <a:spcPts val="1000"/>
+              </a:spcBef>
+              <a:spcAft>
+                <a:spcPts val="0"/>
+              </a:spcAft>
+              <a:buClrTx/>
+              <a:buSzTx/>
+              <a:buFont typeface="Arial" panose="020B0604020202020204" pitchFamily="34" charset="0"/>
+              <a:buNone/>
+              <a:tabLst/>
+              <a:defRPr/>
+            </a:pPr>
+            <a:r>
+              <a:rPr lang="en-US" sz="2800" b="0" cap="none" spc="0" dirty="0">
+                <a:solidFill>
+                  <a:srgbClr val="444742"/>
+                </a:solidFill>
+                <a:latin typeface="Univers Condensed Light"/>
+              </a:rPr>
+              <a:t>Traffic Video Input</a:t>
+            </a:r>
+            <a:endParaRPr kumimoji="0" lang="en-US" sz="2800" b="0" i="0" u="none" strike="noStrike" kern="1200" cap="none" spc="0" normalizeH="0" baseline="0" noProof="0" dirty="0">
+              <a:ln>
+                <a:noFill/>
+              </a:ln>
+              <a:solidFill>
+                <a:srgbClr val="444742"/>
+              </a:solidFill>
+              <a:effectLst/>
+              <a:uLnTx/>
+              <a:uFillTx/>
+              <a:latin typeface="Univers Condensed Light"/>
+              <a:ea typeface="+mn-ea"/>
+              <a:cs typeface="+mn-cs"/>
+            </a:endParaRPr>
+          </a:p>
+        </p:txBody>
+      </p:sp>
+      <p:sp>
+        <p:nvSpPr>
+          <p:cNvPr id="3" name="Content Placeholder 2">
+            <a:extLst>
+              <a:ext uri="{FF2B5EF4-FFF2-40B4-BE49-F238E27FC236}">
+                <a16:creationId xmlns:a16="http://schemas.microsoft.com/office/drawing/2014/main" id="{9B599297-9B04-6E34-D42D-263741081DD7}"/>
+              </a:ext>
+            </a:extLst>
+          </p:cNvPr>
+          <p:cNvSpPr>
+            <a:spLocks noGrp="1"/>
+          </p:cNvSpPr>
+          <p:nvPr>
+            <p:ph sz="half" idx="2"/>
+          </p:nvPr>
+        </p:nvSpPr>
+        <p:spPr>
+          <a:xfrm>
+            <a:off x="621858" y="2139436"/>
+            <a:ext cx="5157787" cy="3495253"/>
+          </a:xfrm>
+        </p:spPr>
+        <p:txBody>
+          <a:bodyPr>
+            <a:normAutofit/>
+          </a:bodyPr>
+          <a:lstStyle/>
+          <a:p>
+            <a:r>
+              <a:rPr lang="en-US" sz="2400" dirty="0"/>
+              <a:t>Analyze a Provided Video</a:t>
+            </a:r>
+          </a:p>
+          <a:p>
+            <a:pPr lvl="1"/>
+            <a:r>
+              <a:rPr lang="en-US" sz="2400" dirty="0"/>
+              <a:t>User Efficiency Tool</a:t>
+            </a:r>
+          </a:p>
+          <a:p>
+            <a:r>
+              <a:rPr lang="en-US" sz="2400" dirty="0"/>
+              <a:t>Determine Traffic Data</a:t>
+            </a:r>
+          </a:p>
+          <a:p>
+            <a:pPr lvl="1"/>
+            <a:r>
+              <a:rPr lang="en-US" sz="2400" dirty="0"/>
+              <a:t>Traffic Flow Directions</a:t>
+            </a:r>
+          </a:p>
+          <a:p>
+            <a:pPr lvl="1"/>
+            <a:r>
+              <a:rPr lang="en-US" sz="2400" dirty="0"/>
+              <a:t>Traffic Density</a:t>
+            </a:r>
+          </a:p>
+          <a:p>
+            <a:r>
+              <a:rPr lang="en-US" sz="2400" dirty="0"/>
+              <a:t>Alter Simulation Parameters to Match</a:t>
+            </a:r>
+          </a:p>
+        </p:txBody>
+      </p:sp>
+      <p:sp>
+        <p:nvSpPr>
+          <p:cNvPr id="5" name="Text Placeholder 4">
+            <a:extLst>
+              <a:ext uri="{FF2B5EF4-FFF2-40B4-BE49-F238E27FC236}">
+                <a16:creationId xmlns:a16="http://schemas.microsoft.com/office/drawing/2014/main" id="{63D3E574-5441-7C65-04F7-1AE5ED31F3EA}"/>
+              </a:ext>
+            </a:extLst>
+          </p:cNvPr>
+          <p:cNvSpPr>
+            <a:spLocks noGrp="1"/>
+          </p:cNvSpPr>
+          <p:nvPr>
+            <p:ph type="body" sz="quarter" idx="3"/>
+          </p:nvPr>
+        </p:nvSpPr>
+        <p:spPr>
+          <a:xfrm>
+            <a:off x="6231402" y="379397"/>
+            <a:ext cx="5183188" cy="709393"/>
+          </a:xfrm>
+        </p:spPr>
+        <p:txBody>
+          <a:bodyPr>
+            <a:normAutofit/>
+          </a:bodyPr>
+          <a:lstStyle/>
+          <a:p>
+            <a:pPr marL="0" marR="0" lvl="0" indent="0" algn="l" defTabSz="914400" rtl="0" eaLnBrk="1" fontAlgn="auto" latinLnBrk="0" hangingPunct="1">
+              <a:lnSpc>
+                <a:spcPct val="120000"/>
+              </a:lnSpc>
+              <a:spcBef>
+                <a:spcPts val="1000"/>
+              </a:spcBef>
+              <a:spcAft>
+                <a:spcPts val="0"/>
+              </a:spcAft>
+              <a:buClrTx/>
+              <a:buSzTx/>
+              <a:buFont typeface="Arial" panose="020B0604020202020204" pitchFamily="34" charset="0"/>
+              <a:buNone/>
+              <a:tabLst/>
+              <a:defRPr/>
+            </a:pPr>
+            <a:r>
+              <a:rPr kumimoji="0" lang="en-US" sz="2800" b="0" i="0" u="none" strike="noStrike" kern="1200" cap="none" spc="0" normalizeH="0" baseline="0" noProof="0" dirty="0">
+                <a:ln>
+                  <a:noFill/>
+                </a:ln>
+                <a:solidFill>
+                  <a:srgbClr val="444742"/>
+                </a:solidFill>
+                <a:effectLst/>
+                <a:uLnTx/>
+                <a:uFillTx/>
+                <a:latin typeface="Univers Condensed Light"/>
+                <a:ea typeface="+mn-ea"/>
+                <a:cs typeface="+mn-cs"/>
+              </a:rPr>
+              <a:t>Layered Roads</a:t>
+            </a:r>
+          </a:p>
+        </p:txBody>
+      </p:sp>
+      <p:sp>
+        <p:nvSpPr>
+          <p:cNvPr id="6" name="Content Placeholder 5">
+            <a:extLst>
+              <a:ext uri="{FF2B5EF4-FFF2-40B4-BE49-F238E27FC236}">
+                <a16:creationId xmlns:a16="http://schemas.microsoft.com/office/drawing/2014/main" id="{455FD4A5-B60E-6DB4-1C59-CDDD2A588E39}"/>
+              </a:ext>
+            </a:extLst>
+          </p:cNvPr>
+          <p:cNvSpPr>
+            <a:spLocks noGrp="1"/>
+          </p:cNvSpPr>
+          <p:nvPr>
+            <p:ph sz="quarter" idx="4"/>
+          </p:nvPr>
+        </p:nvSpPr>
+        <p:spPr>
+          <a:xfrm>
+            <a:off x="6231402" y="1138171"/>
+            <a:ext cx="5183188" cy="3495254"/>
+          </a:xfrm>
+        </p:spPr>
+        <p:txBody>
+          <a:bodyPr>
+            <a:normAutofit/>
+          </a:bodyPr>
+          <a:lstStyle/>
+          <a:p>
+            <a:pPr marL="228600" marR="0" lvl="0" indent="-228600" algn="l" defTabSz="914400" rtl="0" eaLnBrk="1" fontAlgn="auto" latinLnBrk="0" hangingPunct="1">
+              <a:lnSpc>
+                <a:spcPct val="120000"/>
+              </a:lnSpc>
+              <a:spcBef>
+                <a:spcPts val="1000"/>
+              </a:spcBef>
+              <a:spcAft>
+                <a:spcPts val="0"/>
+              </a:spcAft>
+              <a:buClrTx/>
+              <a:buSzTx/>
+              <a:buFont typeface="Arial" panose="020B0604020202020204" pitchFamily="34" charset="0"/>
+              <a:buChar char="•"/>
+              <a:tabLst/>
+              <a:defRPr/>
+            </a:pPr>
+            <a:r>
+              <a:rPr kumimoji="0" lang="en-US" sz="2400" b="0" i="0" u="none" strike="noStrike" kern="1200" cap="none" spc="0" normalizeH="0" baseline="0" noProof="0" dirty="0">
+                <a:ln>
+                  <a:noFill/>
+                </a:ln>
+                <a:solidFill>
+                  <a:srgbClr val="444742"/>
+                </a:solidFill>
+                <a:effectLst/>
+                <a:uLnTx/>
+                <a:uFillTx/>
+                <a:latin typeface="Univers Condensed Light"/>
+                <a:ea typeface="+mn-ea"/>
+                <a:cs typeface="+mn-cs"/>
+              </a:rPr>
+              <a:t>Add </a:t>
+            </a:r>
+            <a:r>
+              <a:rPr lang="en-US" sz="2400" dirty="0">
+                <a:solidFill>
+                  <a:srgbClr val="444742"/>
+                </a:solidFill>
+                <a:latin typeface="Univers Condensed Light"/>
+              </a:rPr>
+              <a:t>Limited Elevation Control to Simulation</a:t>
+            </a:r>
+          </a:p>
+          <a:p>
+            <a:pPr lvl="1">
+              <a:spcBef>
+                <a:spcPts val="1000"/>
+              </a:spcBef>
+              <a:defRPr/>
+            </a:pPr>
+            <a:r>
+              <a:rPr lang="en-US" sz="2400" dirty="0">
+                <a:solidFill>
+                  <a:srgbClr val="444742"/>
+                </a:solidFill>
+                <a:latin typeface="Univers Condensed Light"/>
+              </a:rPr>
+              <a:t>Overpasses</a:t>
+            </a:r>
+          </a:p>
+          <a:p>
+            <a:pPr lvl="1">
+              <a:spcBef>
+                <a:spcPts val="1000"/>
+              </a:spcBef>
+              <a:defRPr/>
+            </a:pPr>
+            <a:r>
+              <a:rPr lang="en-US" sz="2400" dirty="0">
+                <a:solidFill>
+                  <a:srgbClr val="444742"/>
+                </a:solidFill>
+                <a:latin typeface="Univers Condensed Light"/>
+              </a:rPr>
+              <a:t>Underpasses</a:t>
+            </a:r>
+          </a:p>
+          <a:p>
+            <a:pPr marL="228600" marR="0" lvl="0" indent="-228600" algn="l" defTabSz="914400" rtl="0" eaLnBrk="1" fontAlgn="auto" latinLnBrk="0" hangingPunct="1">
+              <a:lnSpc>
+                <a:spcPct val="120000"/>
+              </a:lnSpc>
+              <a:spcBef>
+                <a:spcPts val="1000"/>
+              </a:spcBef>
+              <a:spcAft>
+                <a:spcPts val="0"/>
+              </a:spcAft>
+              <a:buClrTx/>
+              <a:buSzTx/>
+              <a:buFont typeface="Arial" panose="020B0604020202020204" pitchFamily="34" charset="0"/>
+              <a:buChar char="•"/>
+              <a:tabLst/>
+              <a:defRPr/>
+            </a:pPr>
+            <a:r>
+              <a:rPr kumimoji="0" lang="en-US" sz="2400" b="0" i="0" u="none" strike="noStrike" kern="1200" cap="none" spc="0" normalizeH="0" baseline="0" noProof="0" dirty="0">
+                <a:ln>
+                  <a:noFill/>
+                </a:ln>
+                <a:solidFill>
+                  <a:srgbClr val="444742"/>
+                </a:solidFill>
+                <a:effectLst/>
+                <a:uLnTx/>
+                <a:uFillTx/>
+                <a:latin typeface="Univers Condensed Light"/>
+                <a:ea typeface="+mn-ea"/>
+                <a:cs typeface="+mn-cs"/>
+              </a:rPr>
+              <a:t>Useful for</a:t>
+            </a:r>
+            <a:r>
+              <a:rPr lang="en-US" sz="2400" dirty="0">
+                <a:solidFill>
+                  <a:srgbClr val="444742"/>
+                </a:solidFill>
+                <a:latin typeface="Univers Condensed Light"/>
+              </a:rPr>
+              <a:t> Highway Intersections</a:t>
+            </a:r>
+          </a:p>
+          <a:p>
+            <a:pPr lvl="1">
+              <a:spcBef>
+                <a:spcPts val="1000"/>
+              </a:spcBef>
+              <a:defRPr/>
+            </a:pPr>
+            <a:r>
+              <a:rPr kumimoji="0" lang="en-US" sz="2400" b="0" i="0" u="none" strike="noStrike" kern="1200" cap="none" spc="0" normalizeH="0" baseline="0" noProof="0" dirty="0">
+                <a:ln>
+                  <a:noFill/>
+                </a:ln>
+                <a:solidFill>
+                  <a:srgbClr val="444742"/>
+                </a:solidFill>
+                <a:effectLst/>
+                <a:uLnTx/>
+                <a:uFillTx/>
+                <a:latin typeface="Univers Condensed Light"/>
+                <a:ea typeface="+mn-ea"/>
+                <a:cs typeface="+mn-cs"/>
+              </a:rPr>
+              <a:t>Dog</a:t>
+            </a:r>
+            <a:r>
+              <a:rPr lang="en-US" sz="2400" dirty="0">
+                <a:solidFill>
+                  <a:srgbClr val="444742"/>
+                </a:solidFill>
+                <a:latin typeface="Univers Condensed Light"/>
+              </a:rPr>
+              <a:t>bone Interchange</a:t>
+            </a:r>
+            <a:endParaRPr kumimoji="0" lang="en-US" sz="2400" b="0" i="0" u="none" strike="noStrike" kern="1200" cap="none" spc="0" normalizeH="0" baseline="0" noProof="0" dirty="0">
+              <a:ln>
+                <a:noFill/>
+              </a:ln>
+              <a:solidFill>
+                <a:srgbClr val="444742"/>
+              </a:solidFill>
+              <a:effectLst/>
+              <a:uLnTx/>
+              <a:uFillTx/>
+              <a:latin typeface="Univers Condensed Light"/>
+              <a:ea typeface="+mn-ea"/>
+              <a:cs typeface="+mn-cs"/>
+            </a:endParaRPr>
+          </a:p>
+        </p:txBody>
+      </p:sp>
+      <p:pic>
+        <p:nvPicPr>
+          <p:cNvPr id="7" name="Picture 6" descr="Dogbone interchange. : r/CitiesSkylines">
+            <a:extLst>
+              <a:ext uri="{FF2B5EF4-FFF2-40B4-BE49-F238E27FC236}">
+                <a16:creationId xmlns:a16="http://schemas.microsoft.com/office/drawing/2014/main" id="{C5F3410A-C7BA-81B4-DEE1-41880DF9F8DC}"/>
+              </a:ext>
+            </a:extLst>
+          </p:cNvPr>
+          <p:cNvPicPr>
+            <a:picLocks noChangeAspect="1"/>
+          </p:cNvPicPr>
+          <p:nvPr/>
+        </p:nvPicPr>
+        <p:blipFill>
+          <a:blip r:embed="rId2"/>
+          <a:srcRect l="22640" t="14930" r="6957" b="28671"/>
+          <a:stretch>
+            <a:fillRect/>
+          </a:stretch>
+        </p:blipFill>
+        <p:spPr>
+          <a:xfrm>
+            <a:off x="6489906" y="4340888"/>
+            <a:ext cx="3879993" cy="1748413"/>
+          </a:xfrm>
+          <a:prstGeom prst="rect">
+            <a:avLst/>
+          </a:prstGeom>
+        </p:spPr>
+      </p:pic>
+    </p:spTree>
+    <p:extLst>
+      <p:ext uri="{BB962C8B-B14F-4D97-AF65-F5344CB8AC3E}">
+        <p14:creationId xmlns:p14="http://schemas.microsoft.com/office/powerpoint/2010/main" val="1910545465"/>
+      </p:ext>
+    </p:extLst>
+  </p:cSld>
+  <p:clrMapOvr>
+    <a:masterClrMapping/>
+  </p:clrMapOvr>
+</p:sld>
+</file>
+
+<file path=ppt/slides/slide4.xml><?xml version="1.0" encoding="utf-8"?>
+<p:sld xmlns:a="http://schemas.openxmlformats.org/drawingml/2006/main" xmlns:r="http://schemas.openxmlformats.org/officeDocument/2006/relationships" xmlns:p="http://schemas.openxmlformats.org/presentationml/2006/main">
+  <p:cSld>
+    <p:spTree>
+      <p:nvGrpSpPr>
+        <p:cNvPr id="1" name="">
+          <a:extLst>
+            <a:ext uri="{FF2B5EF4-FFF2-40B4-BE49-F238E27FC236}">
+              <a16:creationId xmlns:a16="http://schemas.microsoft.com/office/drawing/2014/main" id="{AD79BFF0-58BA-59B2-382E-27F20F46E56E}"/>
+            </a:ext>
+          </a:extLst>
+        </p:cNvPr>
+        <p:cNvGrpSpPr/>
+        <p:nvPr/>
+      </p:nvGrpSpPr>
+      <p:grpSpPr>
+        <a:xfrm>
+          <a:off x="0" y="0"/>
+          <a:ext cx="0" cy="0"/>
+          <a:chOff x="0" y="0"/>
+          <a:chExt cx="0" cy="0"/>
+        </a:xfrm>
+      </p:grpSpPr>
+      <p:sp>
+        <p:nvSpPr>
+          <p:cNvPr id="2" name="Title 1">
+            <a:extLst>
+              <a:ext uri="{FF2B5EF4-FFF2-40B4-BE49-F238E27FC236}">
+                <a16:creationId xmlns:a16="http://schemas.microsoft.com/office/drawing/2014/main" id="{AB2C87D0-18DD-190D-8277-5E27B3276417}"/>
+              </a:ext>
+            </a:extLst>
+          </p:cNvPr>
+          <p:cNvSpPr>
+            <a:spLocks noGrp="1"/>
+          </p:cNvSpPr>
+          <p:nvPr>
+            <p:ph type="title"/>
+          </p:nvPr>
+        </p:nvSpPr>
+        <p:spPr>
+          <a:xfrm>
+            <a:off x="605431" y="274926"/>
+            <a:ext cx="5355169" cy="1069848"/>
+          </a:xfrm>
+        </p:spPr>
+        <p:txBody>
+          <a:bodyPr>
+            <a:normAutofit/>
+          </a:bodyPr>
+          <a:lstStyle/>
+          <a:p>
+            <a:r>
+              <a:rPr lang="en-US" sz="4000" dirty="0"/>
+              <a:t>Stretch Goals: Part II</a:t>
+            </a:r>
+          </a:p>
+        </p:txBody>
+      </p:sp>
+      <p:sp>
+        <p:nvSpPr>
+          <p:cNvPr id="4" name="Text Placeholder 3">
+            <a:extLst>
+              <a:ext uri="{FF2B5EF4-FFF2-40B4-BE49-F238E27FC236}">
+                <a16:creationId xmlns:a16="http://schemas.microsoft.com/office/drawing/2014/main" id="{DEFF4969-79BF-C3EA-FE54-382BB3EF7853}"/>
+              </a:ext>
+            </a:extLst>
+          </p:cNvPr>
+          <p:cNvSpPr>
+            <a:spLocks noGrp="1"/>
+          </p:cNvSpPr>
+          <p:nvPr>
+            <p:ph type="body" idx="1"/>
+          </p:nvPr>
+        </p:nvSpPr>
+        <p:spPr>
+          <a:xfrm>
+            <a:off x="605431" y="1387408"/>
+            <a:ext cx="5157787" cy="709394"/>
+          </a:xfrm>
+        </p:spPr>
+        <p:txBody>
+          <a:bodyPr>
+            <a:normAutofit/>
+          </a:bodyPr>
+          <a:lstStyle/>
+          <a:p>
+            <a:pPr marL="0" marR="0" lvl="0" indent="0" algn="l" defTabSz="914400" rtl="0" eaLnBrk="1" fontAlgn="auto" latinLnBrk="0" hangingPunct="1">
+              <a:lnSpc>
+                <a:spcPct val="120000"/>
+              </a:lnSpc>
+              <a:spcBef>
+                <a:spcPts val="1000"/>
+              </a:spcBef>
+              <a:spcAft>
+                <a:spcPts val="0"/>
+              </a:spcAft>
+              <a:buClrTx/>
+              <a:buSzTx/>
+              <a:buFont typeface="Arial" panose="020B0604020202020204" pitchFamily="34" charset="0"/>
+              <a:buNone/>
+              <a:tabLst/>
+              <a:defRPr/>
+            </a:pPr>
+            <a:r>
+              <a:rPr kumimoji="0" lang="en-US" sz="2800" b="0" i="0" u="none" strike="noStrike" kern="1200" cap="none" spc="0" normalizeH="0" baseline="0" noProof="0" dirty="0">
+                <a:ln>
+                  <a:noFill/>
+                </a:ln>
+                <a:solidFill>
+                  <a:srgbClr val="444742"/>
+                </a:solidFill>
+                <a:effectLst/>
+                <a:uLnTx/>
+                <a:uFillTx/>
+                <a:latin typeface="Univers Condensed Light"/>
+                <a:ea typeface="+mn-ea"/>
+                <a:cs typeface="+mn-cs"/>
+              </a:rPr>
+              <a:t>Design Suggestions</a:t>
+            </a:r>
+          </a:p>
+        </p:txBody>
+      </p:sp>
+      <p:sp>
+        <p:nvSpPr>
+          <p:cNvPr id="3" name="Content Placeholder 2">
+            <a:extLst>
+              <a:ext uri="{FF2B5EF4-FFF2-40B4-BE49-F238E27FC236}">
+                <a16:creationId xmlns:a16="http://schemas.microsoft.com/office/drawing/2014/main" id="{070FC9F8-DE2A-C4CE-570F-9146F3E802C7}"/>
+              </a:ext>
+            </a:extLst>
+          </p:cNvPr>
+          <p:cNvSpPr>
+            <a:spLocks noGrp="1"/>
+          </p:cNvSpPr>
+          <p:nvPr>
+            <p:ph sz="half" idx="2"/>
+          </p:nvPr>
+        </p:nvSpPr>
+        <p:spPr>
+          <a:xfrm>
+            <a:off x="621858" y="2139436"/>
+            <a:ext cx="5157787" cy="3495253"/>
+          </a:xfrm>
+        </p:spPr>
+        <p:txBody>
+          <a:bodyPr>
+            <a:normAutofit/>
+          </a:bodyPr>
+          <a:lstStyle/>
+          <a:p>
+            <a:r>
+              <a:rPr lang="en-US" sz="2400" dirty="0"/>
+              <a:t>Algorithm Testing Common Intersections</a:t>
+            </a:r>
+          </a:p>
+          <a:p>
+            <a:pPr lvl="1"/>
+            <a:r>
+              <a:rPr lang="en-US" sz="2400" dirty="0"/>
+              <a:t>Intersection Types Predetermined</a:t>
+            </a:r>
+          </a:p>
+          <a:p>
+            <a:r>
+              <a:rPr lang="en-US" sz="2400" dirty="0"/>
+              <a:t>Uses Simulation Feature</a:t>
+            </a:r>
+          </a:p>
+          <a:p>
+            <a:r>
+              <a:rPr lang="en-US" sz="2400" dirty="0"/>
+              <a:t>Returns Best Resulting Intersection</a:t>
+            </a:r>
+          </a:p>
+        </p:txBody>
+      </p:sp>
+      <p:sp>
+        <p:nvSpPr>
+          <p:cNvPr id="5" name="Text Placeholder 4">
+            <a:extLst>
+              <a:ext uri="{FF2B5EF4-FFF2-40B4-BE49-F238E27FC236}">
+                <a16:creationId xmlns:a16="http://schemas.microsoft.com/office/drawing/2014/main" id="{6E560669-2257-4D6E-BB1D-747CDCC23DBC}"/>
+              </a:ext>
+            </a:extLst>
+          </p:cNvPr>
+          <p:cNvSpPr>
+            <a:spLocks noGrp="1"/>
+          </p:cNvSpPr>
+          <p:nvPr>
+            <p:ph type="body" sz="quarter" idx="3"/>
+          </p:nvPr>
+        </p:nvSpPr>
+        <p:spPr>
+          <a:xfrm>
+            <a:off x="6231402" y="1387408"/>
+            <a:ext cx="5183188" cy="709393"/>
+          </a:xfrm>
+        </p:spPr>
+        <p:txBody>
+          <a:bodyPr>
+            <a:normAutofit/>
+          </a:bodyPr>
+          <a:lstStyle/>
+          <a:p>
+            <a:pPr marL="0" marR="0" lvl="0" indent="0" algn="l" defTabSz="914400" rtl="0" eaLnBrk="1" fontAlgn="auto" latinLnBrk="0" hangingPunct="1">
+              <a:lnSpc>
+                <a:spcPct val="120000"/>
+              </a:lnSpc>
+              <a:spcBef>
+                <a:spcPts val="1000"/>
+              </a:spcBef>
+              <a:spcAft>
+                <a:spcPts val="0"/>
+              </a:spcAft>
+              <a:buClrTx/>
+              <a:buSzTx/>
+              <a:buFont typeface="Arial" panose="020B0604020202020204" pitchFamily="34" charset="0"/>
+              <a:buNone/>
+              <a:tabLst/>
+              <a:defRPr/>
+            </a:pPr>
+            <a:r>
+              <a:rPr kumimoji="0" lang="en-US" sz="2800" b="0" i="0" u="none" strike="noStrike" kern="1200" cap="none" spc="0" normalizeH="0" baseline="0" noProof="0" dirty="0">
+                <a:ln>
+                  <a:noFill/>
+                </a:ln>
+                <a:solidFill>
+                  <a:srgbClr val="444742"/>
+                </a:solidFill>
+                <a:effectLst/>
+                <a:uLnTx/>
+                <a:uFillTx/>
+                <a:latin typeface="Univers Condensed Light"/>
+                <a:ea typeface="+mn-ea"/>
+                <a:cs typeface="+mn-cs"/>
+              </a:rPr>
+              <a:t>Advanced Pedestrian Support</a:t>
+            </a:r>
+          </a:p>
+        </p:txBody>
+      </p:sp>
+      <p:sp>
+        <p:nvSpPr>
+          <p:cNvPr id="6" name="Content Placeholder 5">
+            <a:extLst>
+              <a:ext uri="{FF2B5EF4-FFF2-40B4-BE49-F238E27FC236}">
+                <a16:creationId xmlns:a16="http://schemas.microsoft.com/office/drawing/2014/main" id="{63ABAEC1-F057-6991-B094-74827E10D0B0}"/>
+              </a:ext>
+            </a:extLst>
+          </p:cNvPr>
+          <p:cNvSpPr>
+            <a:spLocks noGrp="1"/>
+          </p:cNvSpPr>
+          <p:nvPr>
+            <p:ph sz="quarter" idx="4"/>
+          </p:nvPr>
+        </p:nvSpPr>
+        <p:spPr>
+          <a:xfrm>
+            <a:off x="6231402" y="2139436"/>
+            <a:ext cx="5183188" cy="3495254"/>
+          </a:xfrm>
+        </p:spPr>
+        <p:txBody>
+          <a:bodyPr>
+            <a:normAutofit/>
+          </a:bodyPr>
+          <a:lstStyle/>
+          <a:p>
+            <a:pPr>
+              <a:defRPr/>
+            </a:pPr>
+            <a:r>
+              <a:rPr lang="en-US" sz="2400" dirty="0">
+                <a:solidFill>
+                  <a:srgbClr val="444742"/>
+                </a:solidFill>
+                <a:latin typeface="Univers Condensed Light"/>
+              </a:rPr>
+              <a:t>More Than One Type of Actor</a:t>
+            </a:r>
+          </a:p>
+          <a:p>
+            <a:pPr>
+              <a:defRPr/>
+            </a:pPr>
+            <a:r>
+              <a:rPr lang="en-US" sz="2400" dirty="0">
+                <a:solidFill>
+                  <a:srgbClr val="444742"/>
+                </a:solidFill>
+                <a:latin typeface="Univers Condensed Light"/>
+              </a:rPr>
+              <a:t>Differing Behavior</a:t>
+            </a:r>
+            <a:endParaRPr lang="en-US" sz="2800" dirty="0">
+              <a:solidFill>
+                <a:srgbClr val="444742"/>
+              </a:solidFill>
+              <a:latin typeface="Univers Condensed Light"/>
+            </a:endParaRPr>
+          </a:p>
+          <a:p>
+            <a:pPr lvl="1">
+              <a:spcBef>
+                <a:spcPts val="1000"/>
+              </a:spcBef>
+              <a:defRPr/>
+            </a:pPr>
+            <a:r>
+              <a:rPr lang="en-US" sz="2400" dirty="0">
+                <a:solidFill>
+                  <a:srgbClr val="444742"/>
+                </a:solidFill>
+                <a:latin typeface="Univers Condensed Light"/>
+              </a:rPr>
+              <a:t>Speed</a:t>
+            </a:r>
+          </a:p>
+          <a:p>
+            <a:pPr lvl="1">
+              <a:spcBef>
+                <a:spcPts val="1000"/>
+              </a:spcBef>
+              <a:defRPr/>
+            </a:pPr>
+            <a:r>
+              <a:rPr lang="en-US" sz="2400" dirty="0">
+                <a:solidFill>
+                  <a:srgbClr val="444742"/>
+                </a:solidFill>
+                <a:latin typeface="Univers Condensed Light"/>
+              </a:rPr>
+              <a:t>Awareness</a:t>
+            </a:r>
+          </a:p>
+          <a:p>
+            <a:pPr lvl="1">
+              <a:spcBef>
+                <a:spcPts val="1000"/>
+              </a:spcBef>
+              <a:defRPr/>
+            </a:pPr>
+            <a:r>
+              <a:rPr lang="en-US" sz="2400" dirty="0">
+                <a:solidFill>
+                  <a:srgbClr val="444742"/>
+                </a:solidFill>
+                <a:latin typeface="Univers Condensed Light"/>
+              </a:rPr>
+              <a:t>Caution</a:t>
+            </a:r>
+          </a:p>
+        </p:txBody>
+      </p:sp>
+    </p:spTree>
+    <p:extLst>
+      <p:ext uri="{BB962C8B-B14F-4D97-AF65-F5344CB8AC3E}">
+        <p14:creationId xmlns:p14="http://schemas.microsoft.com/office/powerpoint/2010/main" val="1572061499"/>
+      </p:ext>
+    </p:extLst>
+  </p:cSld>
+  <p:clrMapOvr>
+    <a:masterClrMapping/>
+  </p:clrMapOvr>
+</p:sld>
+</file>
+
 <file path=ppt/theme/theme1.xml><?xml version="1.0" encoding="utf-8"?>
 <a:theme xmlns:a="http://schemas.openxmlformats.org/drawingml/2006/main" name="Orange Experience">
   <a:themeElements>

</xml_diff>

<commit_message>
Pull slides from main
</commit_message>
<xml_diff>
--- a/Traffic Sim.pptx
+++ b/Traffic Sim.pptx
@@ -7,6 +7,11 @@
   <p:sldIdLst>
     <p:sldId id="256" r:id="rId2"/>
     <p:sldId id="257" r:id="rId3"/>
+    <p:sldId id="261" r:id="rId4"/>
+    <p:sldId id="262" r:id="rId5"/>
+    <p:sldId id="263" r:id="rId6"/>
+    <p:sldId id="258" r:id="rId7"/>
+    <p:sldId id="259" r:id="rId8"/>
   </p:sldIdLst>
   <p:sldSz cx="12192000" cy="6858000"/>
   <p:notesSz cx="6858000" cy="9144000"/>
@@ -10173,6 +10178,1312 @@
 </p:sld>
 </file>
 
+<file path=ppt/slides/slide3.xml><?xml version="1.0" encoding="utf-8"?>
+<p:sld xmlns:a="http://schemas.openxmlformats.org/drawingml/2006/main" xmlns:r="http://schemas.openxmlformats.org/officeDocument/2006/relationships" xmlns:p="http://schemas.openxmlformats.org/presentationml/2006/main">
+  <p:cSld>
+    <p:spTree>
+      <p:nvGrpSpPr>
+        <p:cNvPr id="1" name=""/>
+        <p:cNvGrpSpPr/>
+        <p:nvPr/>
+      </p:nvGrpSpPr>
+      <p:grpSpPr>
+        <a:xfrm>
+          <a:off x="0" y="0"/>
+          <a:ext cx="0" cy="0"/>
+          <a:chOff x="0" y="0"/>
+          <a:chExt cx="0" cy="0"/>
+        </a:xfrm>
+      </p:grpSpPr>
+      <p:sp>
+        <p:nvSpPr>
+          <p:cNvPr id="2" name="Title 1">
+            <a:extLst>
+              <a:ext uri="{FF2B5EF4-FFF2-40B4-BE49-F238E27FC236}">
+                <a16:creationId xmlns:a16="http://schemas.microsoft.com/office/drawing/2014/main" id="{017A6928-A1FD-AFE4-7BFB-C26DA00157E2}"/>
+              </a:ext>
+            </a:extLst>
+          </p:cNvPr>
+          <p:cNvSpPr>
+            <a:spLocks noGrp="1"/>
+          </p:cNvSpPr>
+          <p:nvPr>
+            <p:ph type="title"/>
+          </p:nvPr>
+        </p:nvSpPr>
+        <p:spPr>
+          <a:xfrm>
+            <a:off x="605431" y="274926"/>
+            <a:ext cx="5355169" cy="1069848"/>
+          </a:xfrm>
+        </p:spPr>
+        <p:txBody>
+          <a:bodyPr>
+            <a:normAutofit/>
+          </a:bodyPr>
+          <a:lstStyle/>
+          <a:p>
+            <a:r>
+              <a:rPr lang="en-US" sz="4000" dirty="0"/>
+              <a:t>Stretch Goals: Part I</a:t>
+            </a:r>
+          </a:p>
+        </p:txBody>
+      </p:sp>
+      <p:sp>
+        <p:nvSpPr>
+          <p:cNvPr id="4" name="Text Placeholder 3">
+            <a:extLst>
+              <a:ext uri="{FF2B5EF4-FFF2-40B4-BE49-F238E27FC236}">
+                <a16:creationId xmlns:a16="http://schemas.microsoft.com/office/drawing/2014/main" id="{05641E9C-7073-207B-41C5-A5A94E56E0B1}"/>
+              </a:ext>
+            </a:extLst>
+          </p:cNvPr>
+          <p:cNvSpPr>
+            <a:spLocks noGrp="1"/>
+          </p:cNvSpPr>
+          <p:nvPr>
+            <p:ph type="body" idx="1"/>
+          </p:nvPr>
+        </p:nvSpPr>
+        <p:spPr>
+          <a:xfrm>
+            <a:off x="605431" y="1387408"/>
+            <a:ext cx="5157787" cy="709394"/>
+          </a:xfrm>
+        </p:spPr>
+        <p:txBody>
+          <a:bodyPr>
+            <a:normAutofit/>
+          </a:bodyPr>
+          <a:lstStyle/>
+          <a:p>
+            <a:pPr marL="0" marR="0" lvl="0" indent="0" algn="l" defTabSz="914400" rtl="0" eaLnBrk="1" fontAlgn="auto" latinLnBrk="0" hangingPunct="1">
+              <a:lnSpc>
+                <a:spcPct val="120000"/>
+              </a:lnSpc>
+              <a:spcBef>
+                <a:spcPts val="1000"/>
+              </a:spcBef>
+              <a:spcAft>
+                <a:spcPts val="0"/>
+              </a:spcAft>
+              <a:buClrTx/>
+              <a:buSzTx/>
+              <a:buFont typeface="Arial" panose="020B0604020202020204" pitchFamily="34" charset="0"/>
+              <a:buNone/>
+              <a:tabLst/>
+              <a:defRPr/>
+            </a:pPr>
+            <a:r>
+              <a:rPr lang="en-US" sz="2800" b="0" cap="none" spc="0" dirty="0">
+                <a:solidFill>
+                  <a:srgbClr val="444742"/>
+                </a:solidFill>
+                <a:latin typeface="Univers Condensed Light"/>
+              </a:rPr>
+              <a:t>Traffic Video Input</a:t>
+            </a:r>
+            <a:endParaRPr kumimoji="0" lang="en-US" sz="2800" b="0" i="0" u="none" strike="noStrike" kern="1200" cap="none" spc="0" normalizeH="0" baseline="0" noProof="0" dirty="0">
+              <a:ln>
+                <a:noFill/>
+              </a:ln>
+              <a:solidFill>
+                <a:srgbClr val="444742"/>
+              </a:solidFill>
+              <a:effectLst/>
+              <a:uLnTx/>
+              <a:uFillTx/>
+              <a:latin typeface="Univers Condensed Light"/>
+              <a:ea typeface="+mn-ea"/>
+              <a:cs typeface="+mn-cs"/>
+            </a:endParaRPr>
+          </a:p>
+        </p:txBody>
+      </p:sp>
+      <p:sp>
+        <p:nvSpPr>
+          <p:cNvPr id="3" name="Content Placeholder 2">
+            <a:extLst>
+              <a:ext uri="{FF2B5EF4-FFF2-40B4-BE49-F238E27FC236}">
+                <a16:creationId xmlns:a16="http://schemas.microsoft.com/office/drawing/2014/main" id="{9B599297-9B04-6E34-D42D-263741081DD7}"/>
+              </a:ext>
+            </a:extLst>
+          </p:cNvPr>
+          <p:cNvSpPr>
+            <a:spLocks noGrp="1"/>
+          </p:cNvSpPr>
+          <p:nvPr>
+            <p:ph sz="half" idx="2"/>
+          </p:nvPr>
+        </p:nvSpPr>
+        <p:spPr>
+          <a:xfrm>
+            <a:off x="621858" y="2139436"/>
+            <a:ext cx="5157787" cy="3495253"/>
+          </a:xfrm>
+        </p:spPr>
+        <p:txBody>
+          <a:bodyPr>
+            <a:normAutofit/>
+          </a:bodyPr>
+          <a:lstStyle/>
+          <a:p>
+            <a:r>
+              <a:rPr lang="en-US" sz="2400" dirty="0"/>
+              <a:t>Analyze a Provided Video</a:t>
+            </a:r>
+          </a:p>
+          <a:p>
+            <a:pPr lvl="1"/>
+            <a:r>
+              <a:rPr lang="en-US" sz="2400" dirty="0"/>
+              <a:t>User Efficiency Tool</a:t>
+            </a:r>
+          </a:p>
+          <a:p>
+            <a:r>
+              <a:rPr lang="en-US" sz="2400" dirty="0"/>
+              <a:t>Determine Traffic Data</a:t>
+            </a:r>
+          </a:p>
+          <a:p>
+            <a:pPr lvl="1"/>
+            <a:r>
+              <a:rPr lang="en-US" sz="2400" dirty="0"/>
+              <a:t>Traffic Flow Directions</a:t>
+            </a:r>
+          </a:p>
+          <a:p>
+            <a:pPr lvl="1"/>
+            <a:r>
+              <a:rPr lang="en-US" sz="2400" dirty="0"/>
+              <a:t>Traffic Density</a:t>
+            </a:r>
+          </a:p>
+          <a:p>
+            <a:r>
+              <a:rPr lang="en-US" sz="2400" dirty="0"/>
+              <a:t>Alter Simulation Parameters to Match</a:t>
+            </a:r>
+          </a:p>
+        </p:txBody>
+      </p:sp>
+      <p:sp>
+        <p:nvSpPr>
+          <p:cNvPr id="5" name="Text Placeholder 4">
+            <a:extLst>
+              <a:ext uri="{FF2B5EF4-FFF2-40B4-BE49-F238E27FC236}">
+                <a16:creationId xmlns:a16="http://schemas.microsoft.com/office/drawing/2014/main" id="{63D3E574-5441-7C65-04F7-1AE5ED31F3EA}"/>
+              </a:ext>
+            </a:extLst>
+          </p:cNvPr>
+          <p:cNvSpPr>
+            <a:spLocks noGrp="1"/>
+          </p:cNvSpPr>
+          <p:nvPr>
+            <p:ph type="body" sz="quarter" idx="3"/>
+          </p:nvPr>
+        </p:nvSpPr>
+        <p:spPr>
+          <a:xfrm>
+            <a:off x="6231402" y="379397"/>
+            <a:ext cx="5183188" cy="709393"/>
+          </a:xfrm>
+        </p:spPr>
+        <p:txBody>
+          <a:bodyPr>
+            <a:normAutofit/>
+          </a:bodyPr>
+          <a:lstStyle/>
+          <a:p>
+            <a:pPr marL="0" marR="0" lvl="0" indent="0" algn="l" defTabSz="914400" rtl="0" eaLnBrk="1" fontAlgn="auto" latinLnBrk="0" hangingPunct="1">
+              <a:lnSpc>
+                <a:spcPct val="120000"/>
+              </a:lnSpc>
+              <a:spcBef>
+                <a:spcPts val="1000"/>
+              </a:spcBef>
+              <a:spcAft>
+                <a:spcPts val="0"/>
+              </a:spcAft>
+              <a:buClrTx/>
+              <a:buSzTx/>
+              <a:buFont typeface="Arial" panose="020B0604020202020204" pitchFamily="34" charset="0"/>
+              <a:buNone/>
+              <a:tabLst/>
+              <a:defRPr/>
+            </a:pPr>
+            <a:r>
+              <a:rPr kumimoji="0" lang="en-US" sz="2800" b="0" i="0" u="none" strike="noStrike" kern="1200" cap="none" spc="0" normalizeH="0" baseline="0" noProof="0" dirty="0">
+                <a:ln>
+                  <a:noFill/>
+                </a:ln>
+                <a:solidFill>
+                  <a:srgbClr val="444742"/>
+                </a:solidFill>
+                <a:effectLst/>
+                <a:uLnTx/>
+                <a:uFillTx/>
+                <a:latin typeface="Univers Condensed Light"/>
+                <a:ea typeface="+mn-ea"/>
+                <a:cs typeface="+mn-cs"/>
+              </a:rPr>
+              <a:t>Layered Roads</a:t>
+            </a:r>
+          </a:p>
+        </p:txBody>
+      </p:sp>
+      <p:sp>
+        <p:nvSpPr>
+          <p:cNvPr id="6" name="Content Placeholder 5">
+            <a:extLst>
+              <a:ext uri="{FF2B5EF4-FFF2-40B4-BE49-F238E27FC236}">
+                <a16:creationId xmlns:a16="http://schemas.microsoft.com/office/drawing/2014/main" id="{455FD4A5-B60E-6DB4-1C59-CDDD2A588E39}"/>
+              </a:ext>
+            </a:extLst>
+          </p:cNvPr>
+          <p:cNvSpPr>
+            <a:spLocks noGrp="1"/>
+          </p:cNvSpPr>
+          <p:nvPr>
+            <p:ph sz="quarter" idx="4"/>
+          </p:nvPr>
+        </p:nvSpPr>
+        <p:spPr>
+          <a:xfrm>
+            <a:off x="6231402" y="1138171"/>
+            <a:ext cx="5183188" cy="3495254"/>
+          </a:xfrm>
+        </p:spPr>
+        <p:txBody>
+          <a:bodyPr>
+            <a:normAutofit/>
+          </a:bodyPr>
+          <a:lstStyle/>
+          <a:p>
+            <a:pPr marL="228600" marR="0" lvl="0" indent="-228600" algn="l" defTabSz="914400" rtl="0" eaLnBrk="1" fontAlgn="auto" latinLnBrk="0" hangingPunct="1">
+              <a:lnSpc>
+                <a:spcPct val="120000"/>
+              </a:lnSpc>
+              <a:spcBef>
+                <a:spcPts val="1000"/>
+              </a:spcBef>
+              <a:spcAft>
+                <a:spcPts val="0"/>
+              </a:spcAft>
+              <a:buClrTx/>
+              <a:buSzTx/>
+              <a:buFont typeface="Arial" panose="020B0604020202020204" pitchFamily="34" charset="0"/>
+              <a:buChar char="•"/>
+              <a:tabLst/>
+              <a:defRPr/>
+            </a:pPr>
+            <a:r>
+              <a:rPr kumimoji="0" lang="en-US" sz="2400" b="0" i="0" u="none" strike="noStrike" kern="1200" cap="none" spc="0" normalizeH="0" baseline="0" noProof="0" dirty="0">
+                <a:ln>
+                  <a:noFill/>
+                </a:ln>
+                <a:solidFill>
+                  <a:srgbClr val="444742"/>
+                </a:solidFill>
+                <a:effectLst/>
+                <a:uLnTx/>
+                <a:uFillTx/>
+                <a:latin typeface="Univers Condensed Light"/>
+                <a:ea typeface="+mn-ea"/>
+                <a:cs typeface="+mn-cs"/>
+              </a:rPr>
+              <a:t>Add </a:t>
+            </a:r>
+            <a:r>
+              <a:rPr lang="en-US" sz="2400" dirty="0">
+                <a:solidFill>
+                  <a:srgbClr val="444742"/>
+                </a:solidFill>
+                <a:latin typeface="Univers Condensed Light"/>
+              </a:rPr>
+              <a:t>Limited Elevation Control to Simulation</a:t>
+            </a:r>
+          </a:p>
+          <a:p>
+            <a:pPr lvl="1">
+              <a:spcBef>
+                <a:spcPts val="1000"/>
+              </a:spcBef>
+              <a:defRPr/>
+            </a:pPr>
+            <a:r>
+              <a:rPr lang="en-US" sz="2400" dirty="0">
+                <a:solidFill>
+                  <a:srgbClr val="444742"/>
+                </a:solidFill>
+                <a:latin typeface="Univers Condensed Light"/>
+              </a:rPr>
+              <a:t>Overpasses</a:t>
+            </a:r>
+          </a:p>
+          <a:p>
+            <a:pPr lvl="1">
+              <a:spcBef>
+                <a:spcPts val="1000"/>
+              </a:spcBef>
+              <a:defRPr/>
+            </a:pPr>
+            <a:r>
+              <a:rPr lang="en-US" sz="2400" dirty="0">
+                <a:solidFill>
+                  <a:srgbClr val="444742"/>
+                </a:solidFill>
+                <a:latin typeface="Univers Condensed Light"/>
+              </a:rPr>
+              <a:t>Underpasses</a:t>
+            </a:r>
+          </a:p>
+          <a:p>
+            <a:pPr marL="228600" marR="0" lvl="0" indent="-228600" algn="l" defTabSz="914400" rtl="0" eaLnBrk="1" fontAlgn="auto" latinLnBrk="0" hangingPunct="1">
+              <a:lnSpc>
+                <a:spcPct val="120000"/>
+              </a:lnSpc>
+              <a:spcBef>
+                <a:spcPts val="1000"/>
+              </a:spcBef>
+              <a:spcAft>
+                <a:spcPts val="0"/>
+              </a:spcAft>
+              <a:buClrTx/>
+              <a:buSzTx/>
+              <a:buFont typeface="Arial" panose="020B0604020202020204" pitchFamily="34" charset="0"/>
+              <a:buChar char="•"/>
+              <a:tabLst/>
+              <a:defRPr/>
+            </a:pPr>
+            <a:r>
+              <a:rPr kumimoji="0" lang="en-US" sz="2400" b="0" i="0" u="none" strike="noStrike" kern="1200" cap="none" spc="0" normalizeH="0" baseline="0" noProof="0" dirty="0">
+                <a:ln>
+                  <a:noFill/>
+                </a:ln>
+                <a:solidFill>
+                  <a:srgbClr val="444742"/>
+                </a:solidFill>
+                <a:effectLst/>
+                <a:uLnTx/>
+                <a:uFillTx/>
+                <a:latin typeface="Univers Condensed Light"/>
+                <a:ea typeface="+mn-ea"/>
+                <a:cs typeface="+mn-cs"/>
+              </a:rPr>
+              <a:t>Useful for</a:t>
+            </a:r>
+            <a:r>
+              <a:rPr lang="en-US" sz="2400" dirty="0">
+                <a:solidFill>
+                  <a:srgbClr val="444742"/>
+                </a:solidFill>
+                <a:latin typeface="Univers Condensed Light"/>
+              </a:rPr>
+              <a:t> Highway Intersections</a:t>
+            </a:r>
+          </a:p>
+          <a:p>
+            <a:pPr lvl="1">
+              <a:spcBef>
+                <a:spcPts val="1000"/>
+              </a:spcBef>
+              <a:defRPr/>
+            </a:pPr>
+            <a:r>
+              <a:rPr kumimoji="0" lang="en-US" sz="2400" b="0" i="0" u="none" strike="noStrike" kern="1200" cap="none" spc="0" normalizeH="0" baseline="0" noProof="0" dirty="0">
+                <a:ln>
+                  <a:noFill/>
+                </a:ln>
+                <a:solidFill>
+                  <a:srgbClr val="444742"/>
+                </a:solidFill>
+                <a:effectLst/>
+                <a:uLnTx/>
+                <a:uFillTx/>
+                <a:latin typeface="Univers Condensed Light"/>
+                <a:ea typeface="+mn-ea"/>
+                <a:cs typeface="+mn-cs"/>
+              </a:rPr>
+              <a:t>Dog</a:t>
+            </a:r>
+            <a:r>
+              <a:rPr lang="en-US" sz="2400" dirty="0">
+                <a:solidFill>
+                  <a:srgbClr val="444742"/>
+                </a:solidFill>
+                <a:latin typeface="Univers Condensed Light"/>
+              </a:rPr>
+              <a:t>bone Interchange</a:t>
+            </a:r>
+            <a:endParaRPr kumimoji="0" lang="en-US" sz="2400" b="0" i="0" u="none" strike="noStrike" kern="1200" cap="none" spc="0" normalizeH="0" baseline="0" noProof="0" dirty="0">
+              <a:ln>
+                <a:noFill/>
+              </a:ln>
+              <a:solidFill>
+                <a:srgbClr val="444742"/>
+              </a:solidFill>
+              <a:effectLst/>
+              <a:uLnTx/>
+              <a:uFillTx/>
+              <a:latin typeface="Univers Condensed Light"/>
+              <a:ea typeface="+mn-ea"/>
+              <a:cs typeface="+mn-cs"/>
+            </a:endParaRPr>
+          </a:p>
+        </p:txBody>
+      </p:sp>
+      <p:pic>
+        <p:nvPicPr>
+          <p:cNvPr id="7" name="Picture 6" descr="Dogbone interchange. : r/CitiesSkylines">
+            <a:extLst>
+              <a:ext uri="{FF2B5EF4-FFF2-40B4-BE49-F238E27FC236}">
+                <a16:creationId xmlns:a16="http://schemas.microsoft.com/office/drawing/2014/main" id="{C5F3410A-C7BA-81B4-DEE1-41880DF9F8DC}"/>
+              </a:ext>
+            </a:extLst>
+          </p:cNvPr>
+          <p:cNvPicPr>
+            <a:picLocks noChangeAspect="1"/>
+          </p:cNvPicPr>
+          <p:nvPr/>
+        </p:nvPicPr>
+        <p:blipFill>
+          <a:blip r:embed="rId2"/>
+          <a:srcRect l="22640" t="14930" r="6957" b="28671"/>
+          <a:stretch>
+            <a:fillRect/>
+          </a:stretch>
+        </p:blipFill>
+        <p:spPr>
+          <a:xfrm>
+            <a:off x="6489906" y="4340888"/>
+            <a:ext cx="3879993" cy="1748413"/>
+          </a:xfrm>
+          <a:prstGeom prst="rect">
+            <a:avLst/>
+          </a:prstGeom>
+        </p:spPr>
+      </p:pic>
+    </p:spTree>
+    <p:extLst>
+      <p:ext uri="{BB962C8B-B14F-4D97-AF65-F5344CB8AC3E}">
+        <p14:creationId xmlns:p14="http://schemas.microsoft.com/office/powerpoint/2010/main" val="1910545465"/>
+      </p:ext>
+    </p:extLst>
+  </p:cSld>
+  <p:clrMapOvr>
+    <a:masterClrMapping/>
+  </p:clrMapOvr>
+</p:sld>
+</file>
+
+<file path=ppt/slides/slide4.xml><?xml version="1.0" encoding="utf-8"?>
+<p:sld xmlns:a="http://schemas.openxmlformats.org/drawingml/2006/main" xmlns:r="http://schemas.openxmlformats.org/officeDocument/2006/relationships" xmlns:p="http://schemas.openxmlformats.org/presentationml/2006/main">
+  <p:cSld>
+    <p:spTree>
+      <p:nvGrpSpPr>
+        <p:cNvPr id="1" name="">
+          <a:extLst>
+            <a:ext uri="{FF2B5EF4-FFF2-40B4-BE49-F238E27FC236}">
+              <a16:creationId xmlns:a16="http://schemas.microsoft.com/office/drawing/2014/main" id="{AD79BFF0-58BA-59B2-382E-27F20F46E56E}"/>
+            </a:ext>
+          </a:extLst>
+        </p:cNvPr>
+        <p:cNvGrpSpPr/>
+        <p:nvPr/>
+      </p:nvGrpSpPr>
+      <p:grpSpPr>
+        <a:xfrm>
+          <a:off x="0" y="0"/>
+          <a:ext cx="0" cy="0"/>
+          <a:chOff x="0" y="0"/>
+          <a:chExt cx="0" cy="0"/>
+        </a:xfrm>
+      </p:grpSpPr>
+      <p:sp>
+        <p:nvSpPr>
+          <p:cNvPr id="2" name="Title 1">
+            <a:extLst>
+              <a:ext uri="{FF2B5EF4-FFF2-40B4-BE49-F238E27FC236}">
+                <a16:creationId xmlns:a16="http://schemas.microsoft.com/office/drawing/2014/main" id="{AB2C87D0-18DD-190D-8277-5E27B3276417}"/>
+              </a:ext>
+            </a:extLst>
+          </p:cNvPr>
+          <p:cNvSpPr>
+            <a:spLocks noGrp="1"/>
+          </p:cNvSpPr>
+          <p:nvPr>
+            <p:ph type="title"/>
+          </p:nvPr>
+        </p:nvSpPr>
+        <p:spPr>
+          <a:xfrm>
+            <a:off x="605431" y="274926"/>
+            <a:ext cx="5355169" cy="1069848"/>
+          </a:xfrm>
+        </p:spPr>
+        <p:txBody>
+          <a:bodyPr>
+            <a:normAutofit/>
+          </a:bodyPr>
+          <a:lstStyle/>
+          <a:p>
+            <a:r>
+              <a:rPr lang="en-US" sz="4000" dirty="0"/>
+              <a:t>Stretch Goals: Part II</a:t>
+            </a:r>
+          </a:p>
+        </p:txBody>
+      </p:sp>
+      <p:sp>
+        <p:nvSpPr>
+          <p:cNvPr id="4" name="Text Placeholder 3">
+            <a:extLst>
+              <a:ext uri="{FF2B5EF4-FFF2-40B4-BE49-F238E27FC236}">
+                <a16:creationId xmlns:a16="http://schemas.microsoft.com/office/drawing/2014/main" id="{DEFF4969-79BF-C3EA-FE54-382BB3EF7853}"/>
+              </a:ext>
+            </a:extLst>
+          </p:cNvPr>
+          <p:cNvSpPr>
+            <a:spLocks noGrp="1"/>
+          </p:cNvSpPr>
+          <p:nvPr>
+            <p:ph type="body" idx="1"/>
+          </p:nvPr>
+        </p:nvSpPr>
+        <p:spPr>
+          <a:xfrm>
+            <a:off x="605431" y="1387408"/>
+            <a:ext cx="5157787" cy="709394"/>
+          </a:xfrm>
+        </p:spPr>
+        <p:txBody>
+          <a:bodyPr>
+            <a:normAutofit/>
+          </a:bodyPr>
+          <a:lstStyle/>
+          <a:p>
+            <a:pPr marL="0" marR="0" lvl="0" indent="0" algn="l" defTabSz="914400" rtl="0" eaLnBrk="1" fontAlgn="auto" latinLnBrk="0" hangingPunct="1">
+              <a:lnSpc>
+                <a:spcPct val="120000"/>
+              </a:lnSpc>
+              <a:spcBef>
+                <a:spcPts val="1000"/>
+              </a:spcBef>
+              <a:spcAft>
+                <a:spcPts val="0"/>
+              </a:spcAft>
+              <a:buClrTx/>
+              <a:buSzTx/>
+              <a:buFont typeface="Arial" panose="020B0604020202020204" pitchFamily="34" charset="0"/>
+              <a:buNone/>
+              <a:tabLst/>
+              <a:defRPr/>
+            </a:pPr>
+            <a:r>
+              <a:rPr kumimoji="0" lang="en-US" sz="2800" b="0" i="0" u="none" strike="noStrike" kern="1200" cap="none" spc="0" normalizeH="0" baseline="0" noProof="0" dirty="0">
+                <a:ln>
+                  <a:noFill/>
+                </a:ln>
+                <a:solidFill>
+                  <a:srgbClr val="444742"/>
+                </a:solidFill>
+                <a:effectLst/>
+                <a:uLnTx/>
+                <a:uFillTx/>
+                <a:latin typeface="Univers Condensed Light"/>
+                <a:ea typeface="+mn-ea"/>
+                <a:cs typeface="+mn-cs"/>
+              </a:rPr>
+              <a:t>Design Suggestions</a:t>
+            </a:r>
+          </a:p>
+        </p:txBody>
+      </p:sp>
+      <p:sp>
+        <p:nvSpPr>
+          <p:cNvPr id="3" name="Content Placeholder 2">
+            <a:extLst>
+              <a:ext uri="{FF2B5EF4-FFF2-40B4-BE49-F238E27FC236}">
+                <a16:creationId xmlns:a16="http://schemas.microsoft.com/office/drawing/2014/main" id="{070FC9F8-DE2A-C4CE-570F-9146F3E802C7}"/>
+              </a:ext>
+            </a:extLst>
+          </p:cNvPr>
+          <p:cNvSpPr>
+            <a:spLocks noGrp="1"/>
+          </p:cNvSpPr>
+          <p:nvPr>
+            <p:ph sz="half" idx="2"/>
+          </p:nvPr>
+        </p:nvSpPr>
+        <p:spPr>
+          <a:xfrm>
+            <a:off x="621858" y="2139436"/>
+            <a:ext cx="5157787" cy="3495253"/>
+          </a:xfrm>
+        </p:spPr>
+        <p:txBody>
+          <a:bodyPr>
+            <a:normAutofit/>
+          </a:bodyPr>
+          <a:lstStyle/>
+          <a:p>
+            <a:r>
+              <a:rPr lang="en-US" sz="2400" dirty="0"/>
+              <a:t>Algorithm Testing Common Intersections</a:t>
+            </a:r>
+          </a:p>
+          <a:p>
+            <a:pPr lvl="1"/>
+            <a:r>
+              <a:rPr lang="en-US" sz="2400" dirty="0"/>
+              <a:t>Intersection Types Predetermined</a:t>
+            </a:r>
+          </a:p>
+          <a:p>
+            <a:r>
+              <a:rPr lang="en-US" sz="2400" dirty="0"/>
+              <a:t>Uses Simulation Feature</a:t>
+            </a:r>
+          </a:p>
+          <a:p>
+            <a:r>
+              <a:rPr lang="en-US" sz="2400" dirty="0"/>
+              <a:t>Returns Best Resulting Intersection</a:t>
+            </a:r>
+          </a:p>
+        </p:txBody>
+      </p:sp>
+      <p:sp>
+        <p:nvSpPr>
+          <p:cNvPr id="5" name="Text Placeholder 4">
+            <a:extLst>
+              <a:ext uri="{FF2B5EF4-FFF2-40B4-BE49-F238E27FC236}">
+                <a16:creationId xmlns:a16="http://schemas.microsoft.com/office/drawing/2014/main" id="{6E560669-2257-4D6E-BB1D-747CDCC23DBC}"/>
+              </a:ext>
+            </a:extLst>
+          </p:cNvPr>
+          <p:cNvSpPr>
+            <a:spLocks noGrp="1"/>
+          </p:cNvSpPr>
+          <p:nvPr>
+            <p:ph type="body" sz="quarter" idx="3"/>
+          </p:nvPr>
+        </p:nvSpPr>
+        <p:spPr>
+          <a:xfrm>
+            <a:off x="6231402" y="1387408"/>
+            <a:ext cx="5183188" cy="709393"/>
+          </a:xfrm>
+        </p:spPr>
+        <p:txBody>
+          <a:bodyPr>
+            <a:normAutofit/>
+          </a:bodyPr>
+          <a:lstStyle/>
+          <a:p>
+            <a:pPr marL="0" marR="0" lvl="0" indent="0" algn="l" defTabSz="914400" rtl="0" eaLnBrk="1" fontAlgn="auto" latinLnBrk="0" hangingPunct="1">
+              <a:lnSpc>
+                <a:spcPct val="120000"/>
+              </a:lnSpc>
+              <a:spcBef>
+                <a:spcPts val="1000"/>
+              </a:spcBef>
+              <a:spcAft>
+                <a:spcPts val="0"/>
+              </a:spcAft>
+              <a:buClrTx/>
+              <a:buSzTx/>
+              <a:buFont typeface="Arial" panose="020B0604020202020204" pitchFamily="34" charset="0"/>
+              <a:buNone/>
+              <a:tabLst/>
+              <a:defRPr/>
+            </a:pPr>
+            <a:r>
+              <a:rPr kumimoji="0" lang="en-US" sz="2800" b="0" i="0" u="none" strike="noStrike" kern="1200" cap="none" spc="0" normalizeH="0" baseline="0" noProof="0" dirty="0">
+                <a:ln>
+                  <a:noFill/>
+                </a:ln>
+                <a:solidFill>
+                  <a:srgbClr val="444742"/>
+                </a:solidFill>
+                <a:effectLst/>
+                <a:uLnTx/>
+                <a:uFillTx/>
+                <a:latin typeface="Univers Condensed Light"/>
+                <a:ea typeface="+mn-ea"/>
+                <a:cs typeface="+mn-cs"/>
+              </a:rPr>
+              <a:t>Advanced Pedestrian Support</a:t>
+            </a:r>
+          </a:p>
+        </p:txBody>
+      </p:sp>
+      <p:sp>
+        <p:nvSpPr>
+          <p:cNvPr id="6" name="Content Placeholder 5">
+            <a:extLst>
+              <a:ext uri="{FF2B5EF4-FFF2-40B4-BE49-F238E27FC236}">
+                <a16:creationId xmlns:a16="http://schemas.microsoft.com/office/drawing/2014/main" id="{63ABAEC1-F057-6991-B094-74827E10D0B0}"/>
+              </a:ext>
+            </a:extLst>
+          </p:cNvPr>
+          <p:cNvSpPr>
+            <a:spLocks noGrp="1"/>
+          </p:cNvSpPr>
+          <p:nvPr>
+            <p:ph sz="quarter" idx="4"/>
+          </p:nvPr>
+        </p:nvSpPr>
+        <p:spPr>
+          <a:xfrm>
+            <a:off x="6231402" y="2139436"/>
+            <a:ext cx="5183188" cy="3495254"/>
+          </a:xfrm>
+        </p:spPr>
+        <p:txBody>
+          <a:bodyPr>
+            <a:normAutofit/>
+          </a:bodyPr>
+          <a:lstStyle/>
+          <a:p>
+            <a:pPr>
+              <a:defRPr/>
+            </a:pPr>
+            <a:r>
+              <a:rPr lang="en-US" sz="2400" dirty="0">
+                <a:solidFill>
+                  <a:srgbClr val="444742"/>
+                </a:solidFill>
+                <a:latin typeface="Univers Condensed Light"/>
+              </a:rPr>
+              <a:t>More Than One Type of Actor</a:t>
+            </a:r>
+          </a:p>
+          <a:p>
+            <a:pPr>
+              <a:defRPr/>
+            </a:pPr>
+            <a:r>
+              <a:rPr lang="en-US" sz="2400" dirty="0">
+                <a:solidFill>
+                  <a:srgbClr val="444742"/>
+                </a:solidFill>
+                <a:latin typeface="Univers Condensed Light"/>
+              </a:rPr>
+              <a:t>Differing Behavior</a:t>
+            </a:r>
+            <a:endParaRPr lang="en-US" sz="2800" dirty="0">
+              <a:solidFill>
+                <a:srgbClr val="444742"/>
+              </a:solidFill>
+              <a:latin typeface="Univers Condensed Light"/>
+            </a:endParaRPr>
+          </a:p>
+          <a:p>
+            <a:pPr lvl="1">
+              <a:spcBef>
+                <a:spcPts val="1000"/>
+              </a:spcBef>
+              <a:defRPr/>
+            </a:pPr>
+            <a:r>
+              <a:rPr lang="en-US" sz="2400" dirty="0">
+                <a:solidFill>
+                  <a:srgbClr val="444742"/>
+                </a:solidFill>
+                <a:latin typeface="Univers Condensed Light"/>
+              </a:rPr>
+              <a:t>Speed</a:t>
+            </a:r>
+          </a:p>
+          <a:p>
+            <a:pPr lvl="1">
+              <a:spcBef>
+                <a:spcPts val="1000"/>
+              </a:spcBef>
+              <a:defRPr/>
+            </a:pPr>
+            <a:r>
+              <a:rPr lang="en-US" sz="2400" dirty="0">
+                <a:solidFill>
+                  <a:srgbClr val="444742"/>
+                </a:solidFill>
+                <a:latin typeface="Univers Condensed Light"/>
+              </a:rPr>
+              <a:t>Awareness</a:t>
+            </a:r>
+          </a:p>
+          <a:p>
+            <a:pPr lvl="1">
+              <a:spcBef>
+                <a:spcPts val="1000"/>
+              </a:spcBef>
+              <a:defRPr/>
+            </a:pPr>
+            <a:r>
+              <a:rPr lang="en-US" sz="2400" dirty="0">
+                <a:solidFill>
+                  <a:srgbClr val="444742"/>
+                </a:solidFill>
+                <a:latin typeface="Univers Condensed Light"/>
+              </a:rPr>
+              <a:t>Caution</a:t>
+            </a:r>
+          </a:p>
+        </p:txBody>
+      </p:sp>
+    </p:spTree>
+    <p:extLst>
+      <p:ext uri="{BB962C8B-B14F-4D97-AF65-F5344CB8AC3E}">
+        <p14:creationId xmlns:p14="http://schemas.microsoft.com/office/powerpoint/2010/main" val="1572061499"/>
+      </p:ext>
+    </p:extLst>
+  </p:cSld>
+  <p:clrMapOvr>
+    <a:masterClrMapping/>
+  </p:clrMapOvr>
+</p:sld>
+</file>
+
+<file path=ppt/slides/slide5.xml><?xml version="1.0" encoding="utf-8"?>
+<p:sld xmlns:a="http://schemas.openxmlformats.org/drawingml/2006/main" xmlns:r="http://schemas.openxmlformats.org/officeDocument/2006/relationships" xmlns:p="http://schemas.openxmlformats.org/presentationml/2006/main">
+  <p:cSld>
+    <p:spTree>
+      <p:nvGrpSpPr>
+        <p:cNvPr id="1" name=""/>
+        <p:cNvGrpSpPr/>
+        <p:nvPr/>
+      </p:nvGrpSpPr>
+      <p:grpSpPr>
+        <a:xfrm>
+          <a:off x="0" y="0"/>
+          <a:ext cx="0" cy="0"/>
+          <a:chOff x="0" y="0"/>
+          <a:chExt cx="0" cy="0"/>
+        </a:xfrm>
+      </p:grpSpPr>
+      <p:sp>
+        <p:nvSpPr>
+          <p:cNvPr id="2" name="Title 1">
+            <a:extLst>
+              <a:ext uri="{FF2B5EF4-FFF2-40B4-BE49-F238E27FC236}">
+                <a16:creationId xmlns:a16="http://schemas.microsoft.com/office/drawing/2014/main" id="{017A6928-A1FD-AFE4-7BFB-C26DA00157E2}"/>
+              </a:ext>
+            </a:extLst>
+          </p:cNvPr>
+          <p:cNvSpPr>
+            <a:spLocks noGrp="1"/>
+          </p:cNvSpPr>
+          <p:nvPr>
+            <p:ph type="title"/>
+          </p:nvPr>
+        </p:nvSpPr>
+        <p:spPr>
+          <a:xfrm>
+            <a:off x="393192" y="346115"/>
+            <a:ext cx="11393424" cy="1494845"/>
+          </a:xfrm>
+        </p:spPr>
+        <p:txBody>
+          <a:bodyPr>
+            <a:normAutofit/>
+          </a:bodyPr>
+          <a:lstStyle/>
+          <a:p>
+            <a:r>
+              <a:rPr lang="en-US" sz="4000" dirty="0"/>
+              <a:t>Signal timing controls</a:t>
+            </a:r>
+          </a:p>
+        </p:txBody>
+      </p:sp>
+      <p:sp>
+        <p:nvSpPr>
+          <p:cNvPr id="3" name="Content Placeholder 2">
+            <a:extLst>
+              <a:ext uri="{FF2B5EF4-FFF2-40B4-BE49-F238E27FC236}">
+                <a16:creationId xmlns:a16="http://schemas.microsoft.com/office/drawing/2014/main" id="{9B599297-9B04-6E34-D42D-263741081DD7}"/>
+              </a:ext>
+            </a:extLst>
+          </p:cNvPr>
+          <p:cNvSpPr>
+            <a:spLocks noGrp="1"/>
+          </p:cNvSpPr>
+          <p:nvPr>
+            <p:ph idx="1"/>
+          </p:nvPr>
+        </p:nvSpPr>
+        <p:spPr>
+          <a:xfrm>
+            <a:off x="722376" y="1331049"/>
+            <a:ext cx="4620091" cy="4443218"/>
+          </a:xfrm>
+        </p:spPr>
+        <p:txBody>
+          <a:bodyPr>
+            <a:normAutofit/>
+          </a:bodyPr>
+          <a:lstStyle/>
+          <a:p>
+            <a:pPr marL="0" indent="0">
+              <a:buNone/>
+            </a:pPr>
+            <a:r>
+              <a:rPr lang="en-US" sz="2400" dirty="0"/>
+              <a:t>Users will be able to change the timing on traffic lights to better suit the intersection they are working on. These lights can be tested at different traffic densities and tested for the best efficiency.   </a:t>
+            </a:r>
+          </a:p>
+        </p:txBody>
+      </p:sp>
+      <p:pic>
+        <p:nvPicPr>
+          <p:cNvPr id="5" name="Picture 4">
+            <a:extLst>
+              <a:ext uri="{FF2B5EF4-FFF2-40B4-BE49-F238E27FC236}">
+                <a16:creationId xmlns:a16="http://schemas.microsoft.com/office/drawing/2014/main" id="{63F11C6D-B445-73A3-6059-6ECC46AB0BCE}"/>
+              </a:ext>
+            </a:extLst>
+          </p:cNvPr>
+          <p:cNvPicPr>
+            <a:picLocks noChangeAspect="1"/>
+          </p:cNvPicPr>
+          <p:nvPr/>
+        </p:nvPicPr>
+        <p:blipFill>
+          <a:blip r:embed="rId2">
+            <a:extLst>
+              <a:ext uri="{28A0092B-C50C-407E-A947-70E740481C1C}">
+                <a14:useLocalDpi xmlns:a14="http://schemas.microsoft.com/office/drawing/2010/main" val="0"/>
+              </a:ext>
+              <a:ext uri="{837473B0-CC2E-450A-ABE3-18F120FF3D39}">
+                <a1611:picAttrSrcUrl xmlns:a1611="http://schemas.microsoft.com/office/drawing/2016/11/main" r:id="rId3"/>
+              </a:ext>
+            </a:extLst>
+          </a:blip>
+          <a:stretch>
+            <a:fillRect/>
+          </a:stretch>
+        </p:blipFill>
+        <p:spPr>
+          <a:xfrm>
+            <a:off x="5671651" y="1091673"/>
+            <a:ext cx="5372100" cy="3581400"/>
+          </a:xfrm>
+          <a:prstGeom prst="rect">
+            <a:avLst/>
+          </a:prstGeom>
+        </p:spPr>
+      </p:pic>
+    </p:spTree>
+    <p:extLst>
+      <p:ext uri="{BB962C8B-B14F-4D97-AF65-F5344CB8AC3E}">
+        <p14:creationId xmlns:p14="http://schemas.microsoft.com/office/powerpoint/2010/main" val="2776897843"/>
+      </p:ext>
+    </p:extLst>
+  </p:cSld>
+  <p:clrMapOvr>
+    <a:masterClrMapping/>
+  </p:clrMapOvr>
+</p:sld>
+</file>
+
+<file path=ppt/slides/slide6.xml><?xml version="1.0" encoding="utf-8"?>
+<p:sld xmlns:a="http://schemas.openxmlformats.org/drawingml/2006/main" xmlns:r="http://schemas.openxmlformats.org/officeDocument/2006/relationships" xmlns:p="http://schemas.openxmlformats.org/presentationml/2006/main">
+  <p:cSld>
+    <p:spTree>
+      <p:nvGrpSpPr>
+        <p:cNvPr id="1" name="">
+          <a:extLst>
+            <a:ext uri="{FF2B5EF4-FFF2-40B4-BE49-F238E27FC236}">
+              <a16:creationId xmlns:a16="http://schemas.microsoft.com/office/drawing/2014/main" id="{6F3F9506-CA50-4E16-C1EE-611F74DBDF93}"/>
+            </a:ext>
+          </a:extLst>
+        </p:cNvPr>
+        <p:cNvGrpSpPr/>
+        <p:nvPr/>
+      </p:nvGrpSpPr>
+      <p:grpSpPr>
+        <a:xfrm>
+          <a:off x="0" y="0"/>
+          <a:ext cx="0" cy="0"/>
+          <a:chOff x="0" y="0"/>
+          <a:chExt cx="0" cy="0"/>
+        </a:xfrm>
+      </p:grpSpPr>
+      <p:sp>
+        <p:nvSpPr>
+          <p:cNvPr id="2" name="Title 1">
+            <a:extLst>
+              <a:ext uri="{FF2B5EF4-FFF2-40B4-BE49-F238E27FC236}">
+                <a16:creationId xmlns:a16="http://schemas.microsoft.com/office/drawing/2014/main" id="{6921D40C-16BE-5FC3-112D-8FA44183E0F5}"/>
+              </a:ext>
+            </a:extLst>
+          </p:cNvPr>
+          <p:cNvSpPr>
+            <a:spLocks noGrp="1"/>
+          </p:cNvSpPr>
+          <p:nvPr>
+            <p:ph type="title"/>
+          </p:nvPr>
+        </p:nvSpPr>
+        <p:spPr>
+          <a:xfrm>
+            <a:off x="393192" y="346115"/>
+            <a:ext cx="11393424" cy="1494845"/>
+          </a:xfrm>
+        </p:spPr>
+        <p:txBody>
+          <a:bodyPr>
+            <a:normAutofit/>
+          </a:bodyPr>
+          <a:lstStyle/>
+          <a:p>
+            <a:r>
+              <a:rPr lang="en-US" sz="4000" dirty="0"/>
+              <a:t>Adjustable traffic volume</a:t>
+            </a:r>
+          </a:p>
+        </p:txBody>
+      </p:sp>
+      <p:sp>
+        <p:nvSpPr>
+          <p:cNvPr id="3" name="Content Placeholder 2">
+            <a:extLst>
+              <a:ext uri="{FF2B5EF4-FFF2-40B4-BE49-F238E27FC236}">
+                <a16:creationId xmlns:a16="http://schemas.microsoft.com/office/drawing/2014/main" id="{6960D1D7-99EE-3C6E-4656-0F9285B80B5C}"/>
+              </a:ext>
+            </a:extLst>
+          </p:cNvPr>
+          <p:cNvSpPr>
+            <a:spLocks noGrp="1"/>
+          </p:cNvSpPr>
+          <p:nvPr>
+            <p:ph idx="1"/>
+          </p:nvPr>
+        </p:nvSpPr>
+        <p:spPr>
+          <a:xfrm>
+            <a:off x="722376" y="1331049"/>
+            <a:ext cx="4620091" cy="4443218"/>
+          </a:xfrm>
+        </p:spPr>
+        <p:txBody>
+          <a:bodyPr>
+            <a:normAutofit/>
+          </a:bodyPr>
+          <a:lstStyle/>
+          <a:p>
+            <a:pPr marL="0" indent="0">
+              <a:buNone/>
+            </a:pPr>
+            <a:r>
+              <a:rPr lang="en-US" sz="2400" dirty="0"/>
+              <a:t>Users will also be able to adjust the density of traffic going through the intersection to better simulate the stress the intersection will have.</a:t>
+            </a:r>
+          </a:p>
+        </p:txBody>
+      </p:sp>
+      <p:pic>
+        <p:nvPicPr>
+          <p:cNvPr id="7" name="Picture 6">
+            <a:extLst>
+              <a:ext uri="{FF2B5EF4-FFF2-40B4-BE49-F238E27FC236}">
+                <a16:creationId xmlns:a16="http://schemas.microsoft.com/office/drawing/2014/main" id="{84A30EC5-8D0C-FDD6-33D3-F4D4A2FE1E28}"/>
+              </a:ext>
+            </a:extLst>
+          </p:cNvPr>
+          <p:cNvPicPr>
+            <a:picLocks noChangeAspect="1"/>
+          </p:cNvPicPr>
+          <p:nvPr/>
+        </p:nvPicPr>
+        <p:blipFill>
+          <a:blip r:embed="rId2">
+            <a:extLst>
+              <a:ext uri="{28A0092B-C50C-407E-A947-70E740481C1C}">
+                <a14:useLocalDpi xmlns:a14="http://schemas.microsoft.com/office/drawing/2010/main" val="0"/>
+              </a:ext>
+              <a:ext uri="{837473B0-CC2E-450A-ABE3-18F120FF3D39}">
+                <a1611:picAttrSrcUrl xmlns:a1611="http://schemas.microsoft.com/office/drawing/2016/11/main" r:id="rId3"/>
+              </a:ext>
+            </a:extLst>
+          </a:blip>
+          <a:stretch>
+            <a:fillRect/>
+          </a:stretch>
+        </p:blipFill>
+        <p:spPr>
+          <a:xfrm>
+            <a:off x="5671651" y="1093537"/>
+            <a:ext cx="5924291" cy="4443218"/>
+          </a:xfrm>
+          <a:prstGeom prst="rect">
+            <a:avLst/>
+          </a:prstGeom>
+        </p:spPr>
+      </p:pic>
+    </p:spTree>
+    <p:extLst>
+      <p:ext uri="{BB962C8B-B14F-4D97-AF65-F5344CB8AC3E}">
+        <p14:creationId xmlns:p14="http://schemas.microsoft.com/office/powerpoint/2010/main" val="1328075336"/>
+      </p:ext>
+    </p:extLst>
+  </p:cSld>
+  <p:clrMapOvr>
+    <a:masterClrMapping/>
+  </p:clrMapOvr>
+</p:sld>
+</file>
+
+<file path=ppt/slides/slide7.xml><?xml version="1.0" encoding="utf-8"?>
+<p:sld xmlns:a="http://schemas.openxmlformats.org/drawingml/2006/main" xmlns:r="http://schemas.openxmlformats.org/officeDocument/2006/relationships" xmlns:p="http://schemas.openxmlformats.org/presentationml/2006/main">
+  <p:cSld>
+    <p:spTree>
+      <p:nvGrpSpPr>
+        <p:cNvPr id="1" name="">
+          <a:extLst>
+            <a:ext uri="{FF2B5EF4-FFF2-40B4-BE49-F238E27FC236}">
+              <a16:creationId xmlns:a16="http://schemas.microsoft.com/office/drawing/2014/main" id="{983E017C-3903-E58C-584A-9A734E63028F}"/>
+            </a:ext>
+          </a:extLst>
+        </p:cNvPr>
+        <p:cNvGrpSpPr/>
+        <p:nvPr/>
+      </p:nvGrpSpPr>
+      <p:grpSpPr>
+        <a:xfrm>
+          <a:off x="0" y="0"/>
+          <a:ext cx="0" cy="0"/>
+          <a:chOff x="0" y="0"/>
+          <a:chExt cx="0" cy="0"/>
+        </a:xfrm>
+      </p:grpSpPr>
+      <p:sp>
+        <p:nvSpPr>
+          <p:cNvPr id="2" name="Title 1">
+            <a:extLst>
+              <a:ext uri="{FF2B5EF4-FFF2-40B4-BE49-F238E27FC236}">
+                <a16:creationId xmlns:a16="http://schemas.microsoft.com/office/drawing/2014/main" id="{AA91F8DB-5CE7-6726-F0B2-7C394FD2BCF6}"/>
+              </a:ext>
+            </a:extLst>
+          </p:cNvPr>
+          <p:cNvSpPr>
+            <a:spLocks noGrp="1"/>
+          </p:cNvSpPr>
+          <p:nvPr>
+            <p:ph type="title"/>
+          </p:nvPr>
+        </p:nvSpPr>
+        <p:spPr>
+          <a:xfrm>
+            <a:off x="393192" y="346115"/>
+            <a:ext cx="11393424" cy="1494845"/>
+          </a:xfrm>
+        </p:spPr>
+        <p:txBody>
+          <a:bodyPr>
+            <a:normAutofit/>
+          </a:bodyPr>
+          <a:lstStyle/>
+          <a:p>
+            <a:r>
+              <a:rPr lang="en-US" sz="4000" dirty="0"/>
+              <a:t>Performance metrics</a:t>
+            </a:r>
+          </a:p>
+        </p:txBody>
+      </p:sp>
+      <p:sp>
+        <p:nvSpPr>
+          <p:cNvPr id="3" name="Content Placeholder 2">
+            <a:extLst>
+              <a:ext uri="{FF2B5EF4-FFF2-40B4-BE49-F238E27FC236}">
+                <a16:creationId xmlns:a16="http://schemas.microsoft.com/office/drawing/2014/main" id="{6C5DE297-F627-8DE9-CC50-42756143C2CC}"/>
+              </a:ext>
+            </a:extLst>
+          </p:cNvPr>
+          <p:cNvSpPr>
+            <a:spLocks noGrp="1"/>
+          </p:cNvSpPr>
+          <p:nvPr>
+            <p:ph idx="1"/>
+          </p:nvPr>
+        </p:nvSpPr>
+        <p:spPr>
+          <a:xfrm>
+            <a:off x="722376" y="1331049"/>
+            <a:ext cx="4620091" cy="4443218"/>
+          </a:xfrm>
+        </p:spPr>
+        <p:txBody>
+          <a:bodyPr>
+            <a:normAutofit fontScale="92500" lnSpcReduction="10000"/>
+          </a:bodyPr>
+          <a:lstStyle/>
+          <a:p>
+            <a:pPr marL="0" indent="0">
+              <a:buNone/>
+            </a:pPr>
+            <a:r>
+              <a:rPr lang="en-US" sz="2400" dirty="0"/>
+              <a:t>The simulation will be able to output performance metrics that show how well the intersection performed under varying amounts of load. </a:t>
+            </a:r>
+          </a:p>
+          <a:p>
+            <a:pPr marL="0" indent="0">
+              <a:buNone/>
+            </a:pPr>
+            <a:r>
+              <a:rPr lang="en-US" sz="2400" dirty="0"/>
+              <a:t>Possible metrics:</a:t>
+            </a:r>
+          </a:p>
+          <a:p>
+            <a:pPr lvl="1"/>
+            <a:r>
+              <a:rPr lang="en-US" sz="2400" dirty="0"/>
+              <a:t>Wait time</a:t>
+            </a:r>
+          </a:p>
+          <a:p>
+            <a:pPr lvl="1"/>
+            <a:r>
+              <a:rPr lang="en-US" sz="2400" dirty="0"/>
+              <a:t>Speed</a:t>
+            </a:r>
+          </a:p>
+          <a:p>
+            <a:pPr lvl="1"/>
+            <a:r>
+              <a:rPr lang="en-US" sz="2400" dirty="0"/>
+              <a:t>Number of vehicles through per amount of time</a:t>
+            </a:r>
+          </a:p>
+          <a:p>
+            <a:pPr lvl="1"/>
+            <a:r>
+              <a:rPr lang="en-US" sz="2400" dirty="0"/>
+              <a:t>Queue length</a:t>
+            </a:r>
+          </a:p>
+        </p:txBody>
+      </p:sp>
+    </p:spTree>
+    <p:extLst>
+      <p:ext uri="{BB962C8B-B14F-4D97-AF65-F5344CB8AC3E}">
+        <p14:creationId xmlns:p14="http://schemas.microsoft.com/office/powerpoint/2010/main" val="2321807993"/>
+      </p:ext>
+    </p:extLst>
+  </p:cSld>
+  <p:clrMapOvr>
+    <a:masterClrMapping/>
+  </p:clrMapOvr>
+</p:sld>
+</file>
+
 <file path=ppt/theme/theme1.xml><?xml version="1.0" encoding="utf-8"?>
 <a:theme xmlns:a="http://schemas.openxmlformats.org/drawingml/2006/main" name="Orange Experience">
   <a:themeElements>

</xml_diff>

<commit_message>
Input and Output Slide
</commit_message>
<xml_diff>
--- a/Traffic Sim.pptx
+++ b/Traffic Sim.pptx
@@ -10067,7 +10067,7 @@
           <a:p>
             <a:r>
               <a:rPr lang="en-US" sz="4000" dirty="0"/>
-              <a:t>Overview</a:t>
+              <a:t>Input and output</a:t>
             </a:r>
           </a:p>
         </p:txBody>
@@ -10102,65 +10102,58 @@
           <a:p>
             <a:r>
               <a:rPr lang="en-US" sz="2400" dirty="0"/>
-              <a:t>Intersection Design</a:t>
+              <a:t>Reference Images</a:t>
             </a:r>
           </a:p>
           <a:p>
             <a:pPr lvl="1"/>
             <a:r>
               <a:rPr lang="en-US" sz="2400" dirty="0"/>
-              <a:t>Create it Visually</a:t>
+              <a:t>Generate from a bird’s-eye view picture of an intersection</a:t>
             </a:r>
           </a:p>
           <a:p>
             <a:pPr lvl="1"/>
             <a:r>
               <a:rPr lang="en-US" sz="2400" dirty="0"/>
-              <a:t>Create it from a Reference</a:t>
+              <a:t>Insert an image to build on</a:t>
             </a:r>
           </a:p>
           <a:p>
             <a:r>
               <a:rPr lang="en-US" sz="2400" dirty="0"/>
-              <a:t>Test Design Effectiveness</a:t>
+              <a:t>Save Designs</a:t>
             </a:r>
           </a:p>
           <a:p>
             <a:pPr lvl="1"/>
             <a:r>
               <a:rPr lang="en-US" sz="2400" dirty="0"/>
-              <a:t>Stress Test</a:t>
+              <a:t>Simulation runs are saved with the design</a:t>
             </a:r>
           </a:p>
           <a:p>
             <a:pPr lvl="1"/>
             <a:r>
               <a:rPr lang="en-US" sz="2400" dirty="0"/>
-              <a:t>Edge Case Searching</a:t>
+              <a:t>Compare designs and associated simulation results</a:t>
             </a:r>
           </a:p>
           <a:p>
             <a:r>
               <a:rPr lang="en-US" sz="2400" dirty="0"/>
-              <a:t>Optimize an Intersection Design</a:t>
+              <a:t>Data Export</a:t>
             </a:r>
           </a:p>
           <a:p>
             <a:pPr lvl="1"/>
             <a:r>
               <a:rPr lang="en-US" sz="2400" dirty="0"/>
-              <a:t>Design and Test Rapidly</a:t>
+              <a:t>Export simulation results to CSV</a:t>
             </a:r>
           </a:p>
           <a:p>
             <a:pPr lvl="1"/>
-            <a:r>
-              <a:rPr lang="en-US" sz="2400"/>
-              <a:t>Bulk Testing</a:t>
-            </a:r>
-            <a:endParaRPr lang="en-US" sz="2400" dirty="0"/>
-          </a:p>
-          <a:p>
             <a:endParaRPr lang="en-US" sz="2400" dirty="0"/>
           </a:p>
         </p:txBody>

</xml_diff>